<commit_message>
Rebuild Session 3.6 from scratch: campus Q&A bot, new corpus, new bug
</commit_message>
<xml_diff>
--- a/slides/week-03/session-3.6.pptx
+++ b/slides/week-03/session-3.6.pptx
@@ -1658,7 +1658,7 @@
     <p:bg>
       <p:bgPr>
         <a:solidFill>
-          <a:srgbClr val="1E2761"/>
+          <a:srgbClr val="4A2545"/>
         </a:solidFill>
       </p:bgPr>
     </p:bg>
@@ -1703,7 +1703,7 @@
             <a:r>
               <a:rPr lang="en-US" sz="1400" b="1" spc="200" kern="0" dirty="0">
                 <a:solidFill>
-                  <a:srgbClr val="F4B942"/>
+                  <a:srgbClr val="E8B339"/>
                 </a:solidFill>
                 <a:latin typeface="Calibri" pitchFamily="34" charset="0"/>
                 <a:ea typeface="Calibri" pitchFamily="34" charset="-122"/>
@@ -1748,7 +1748,7 @@
                 <a:ea typeface="Cambria" pitchFamily="34" charset="-122"/>
                 <a:cs typeface="Cambria" pitchFamily="34" charset="-120"/>
               </a:rPr>
-              <a:t>Building a Company Policy Q&amp;A Bot</a:t>
+              <a:t>Campus Student Services Q&amp;A Bot</a:t>
             </a:r>
             <a:endParaRPr lang="en-US" sz="4200" dirty="0"/>
           </a:p>
@@ -1784,13 +1784,13 @@
             <a:r>
               <a:rPr lang="en-US" sz="1700" i="1" dirty="0">
                 <a:solidFill>
-                  <a:srgbClr val="CADCFC"/>
-                </a:solidFill>
-                <a:latin typeface="Calibri" pitchFamily="34" charset="0"/>
-                <a:ea typeface="Calibri" pitchFamily="34" charset="-122"/>
-                <a:cs typeface="Calibri" pitchFamily="34" charset="-120"/>
-              </a:rPr>
-              <a:t>Every piece you built this week, working together over four real policy documents — and a retrieval bug you'll have to find yourself.</a:t>
+                  <a:srgbClr val="FBF3E7"/>
+                </a:solidFill>
+                <a:latin typeface="Calibri" pitchFamily="34" charset="0"/>
+                <a:ea typeface="Calibri" pitchFamily="34" charset="-122"/>
+                <a:cs typeface="Calibri" pitchFamily="34" charset="-120"/>
+              </a:rPr>
+              <a:t>Four campus documents that genuinely cross-reference each other — and a retrieval bug hiding in exactly that overlap.</a:t>
             </a:r>
             <a:endParaRPr lang="en-US" sz="1700" dirty="0"/>
           </a:p>
@@ -1811,14 +1811,14 @@
             <a:avLst/>
           </a:prstGeom>
           <a:solidFill>
-            <a:srgbClr val="FF6B6B"/>
+            <a:srgbClr val="C45B6E"/>
           </a:solidFill>
           <a:ln/>
         </p:spPr>
       </p:sp>
       <p:pic>
         <p:nvPicPr>
-          <p:cNvPr id="6" name="Image 0" descr="icon_home_white.png">    </p:cNvPr>
+          <p:cNvPr id="6" name="Image 0" descr="icon_clipboard_white.png">    </p:cNvPr>
           <p:cNvPicPr>
             <a:picLocks noChangeAspect="1"/>
           </p:cNvPicPr>
@@ -1873,7 +1873,7 @@
                 <a:ea typeface="Calibri" pitchFamily="34" charset="-122"/>
                 <a:cs typeface="Calibri" pitchFamily="34" charset="-120"/>
               </a:rPr>
-              <a:t>Remote Work</a:t>
+              <a:t>Registration</a:t>
             </a:r>
             <a:endParaRPr lang="en-US" sz="1300" dirty="0"/>
           </a:p>
@@ -1894,7 +1894,7 @@
             <a:avLst/>
           </a:prstGeom>
           <a:solidFill>
-            <a:srgbClr val="FF6B6B"/>
+            <a:srgbClr val="C45B6E"/>
           </a:solidFill>
           <a:ln/>
         </p:spPr>
@@ -1956,7 +1956,7 @@
                 <a:ea typeface="Calibri" pitchFamily="34" charset="-122"/>
                 <a:cs typeface="Calibri" pitchFamily="34" charset="-120"/>
               </a:rPr>
-              <a:t>Expenses</a:t>
+              <a:t>Financial Aid</a:t>
             </a:r>
             <a:endParaRPr lang="en-US" sz="1300" dirty="0"/>
           </a:p>
@@ -1977,14 +1977,14 @@
             <a:avLst/>
           </a:prstGeom>
           <a:solidFill>
-            <a:srgbClr val="FF6B6B"/>
+            <a:srgbClr val="C45B6E"/>
           </a:solidFill>
           <a:ln/>
         </p:spPr>
       </p:sp>
       <p:pic>
         <p:nvPicPr>
-          <p:cNvPr id="12" name="Image 2" descr="icon_umbrella_white.png">    </p:cNvPr>
+          <p:cNvPr id="12" name="Image 2" descr="icon_usergrad_white.png">    </p:cNvPr>
           <p:cNvPicPr>
             <a:picLocks noChangeAspect="1"/>
           </p:cNvPicPr>
@@ -2039,7 +2039,7 @@
                 <a:ea typeface="Calibri" pitchFamily="34" charset="-122"/>
                 <a:cs typeface="Calibri" pitchFamily="34" charset="-120"/>
               </a:rPr>
-              <a:t>Leave</a:t>
+              <a:t>Academic Standing</a:t>
             </a:r>
             <a:endParaRPr lang="en-US" sz="1300" dirty="0"/>
           </a:p>
@@ -2060,14 +2060,14 @@
             <a:avLst/>
           </a:prstGeom>
           <a:solidFill>
-            <a:srgbClr val="FF6B6B"/>
+            <a:srgbClr val="C45B6E"/>
           </a:solidFill>
           <a:ln/>
         </p:spPr>
       </p:sp>
       <p:pic>
         <p:nvPicPr>
-          <p:cNvPr id="15" name="Image 3" descr="icon_shield_white.png">    </p:cNvPr>
+          <p:cNvPr id="15" name="Image 3" descr="icon_bed_white.png">    </p:cNvPr>
           <p:cNvPicPr>
             <a:picLocks noChangeAspect="1"/>
           </p:cNvPicPr>
@@ -2122,7 +2122,7 @@
                 <a:ea typeface="Calibri" pitchFamily="34" charset="-122"/>
                 <a:cs typeface="Calibri" pitchFamily="34" charset="-120"/>
               </a:rPr>
-              <a:t>IT Security</a:t>
+              <a:t>Housing</a:t>
             </a:r>
             <a:endParaRPr lang="en-US" sz="1300" dirty="0"/>
           </a:p>
@@ -2155,7 +2155,7 @@
             <a:r>
               <a:rPr lang="en-US" sz="1200" dirty="0">
                 <a:solidFill>
-                  <a:srgbClr val="CADCFC"/>
+                  <a:srgbClr val="FBF3E7"/>
                 </a:solidFill>
                 <a:latin typeface="Calibri" pitchFamily="34" charset="0"/>
                 <a:ea typeface="Calibri" pitchFamily="34" charset="-122"/>
@@ -2181,7 +2181,7 @@
     <p:bg>
       <p:bgPr>
         <a:solidFill>
-          <a:srgbClr val="1E2761"/>
+          <a:srgbClr val="4A2545"/>
         </a:solidFill>
       </p:bgPr>
     </p:bg>
@@ -2253,7 +2253,7 @@
             <a:avLst/>
           </a:prstGeom>
           <a:solidFill>
-            <a:srgbClr val="FF6B6B"/>
+            <a:srgbClr val="C45B6E"/>
           </a:solidFill>
           <a:ln/>
         </p:spPr>
@@ -2333,7 +2333,7 @@
                 <a:ea typeface="Calibri" pitchFamily="34" charset="-122"/>
                 <a:cs typeface="Calibri" pitchFamily="34" charset="-120"/>
               </a:rPr>
-              <a:t>There's no universal chunking strategy — match it to how your real source documents are structured, especially for PDFs.</a:t>
+              <a:t>Multi-document retrieval can confidently return the wrong source — harder to spot than an imprecise chunk from the right one.</a:t>
             </a:r>
             <a:endParaRPr lang="en-US" sz="1450" dirty="0"/>
           </a:p>
@@ -2354,7 +2354,7 @@
             <a:avLst/>
           </a:prstGeom>
           <a:solidFill>
-            <a:srgbClr val="FF6B6B"/>
+            <a:srgbClr val="C45B6E"/>
           </a:solidFill>
           <a:ln/>
         </p:spPr>
@@ -2434,7 +2434,7 @@
                 <a:ea typeface="Calibri" pitchFamily="34" charset="-122"/>
                 <a:cs typeface="Calibri" pitchFamily="34" charset="-120"/>
               </a:rPr>
-              <a:t>Multi-document retrieval can confidently return the wrong source, which is harder to spot than an imprecise chunk.</a:t>
+              <a:t>There's no universal chunking fix, only a universal principle: match your strategy to how your real documents are structured.</a:t>
             </a:r>
             <a:endParaRPr lang="en-US" sz="1450" dirty="0"/>
           </a:p>
@@ -2455,7 +2455,7 @@
             <a:avLst/>
           </a:prstGeom>
           <a:solidFill>
-            <a:srgbClr val="FF6B6B"/>
+            <a:srgbClr val="C45B6E"/>
           </a:solidFill>
           <a:ln/>
         </p:spPr>
@@ -2535,7 +2535,7 @@
                 <a:ea typeface="Calibri" pitchFamily="34" charset="-122"/>
                 <a:cs typeface="Calibri" pitchFamily="34" charset="-120"/>
               </a:rPr>
-              <a:t>Source-document labels on citations turn a silent failure into a visible one, at no real engineering cost.</a:t>
+              <a:t>Source-document labels on citations turn a silent wrong-document failure into something visible at a glance.</a:t>
             </a:r>
             <a:endParaRPr lang="en-US" sz="1450" dirty="0"/>
           </a:p>
@@ -2585,7 +2585,7 @@
             <a:avLst/>
           </a:prstGeom>
           <a:solidFill>
-            <a:srgbClr val="F4B942"/>
+            <a:srgbClr val="E8B339"/>
           </a:solidFill>
           <a:ln/>
         </p:spPr>
@@ -2641,7 +2641,7 @@
             <a:r>
               <a:rPr lang="en-US" sz="1700" b="1" dirty="0">
                 <a:solidFill>
-                  <a:srgbClr val="232B45"/>
+                  <a:srgbClr val="2B1A2E"/>
                 </a:solidFill>
                 <a:latin typeface="Calibri" pitchFamily="34" charset="0"/>
                 <a:ea typeface="Calibri" pitchFamily="34" charset="-122"/>
@@ -2683,13 +2683,13 @@
             <a:r>
               <a:rPr lang="en-US" sz="1300" i="1" dirty="0">
                 <a:solidFill>
-                  <a:srgbClr val="6B7280"/>
-                </a:solidFill>
-                <a:latin typeface="Calibri" pitchFamily="34" charset="0"/>
-                <a:ea typeface="Calibri" pitchFamily="34" charset="-122"/>
-                <a:cs typeface="Calibri" pitchFamily="34" charset="-120"/>
-              </a:rPr>
-              <a:t>You spent this week teaching a model to find and use the right information. Next week, you'll teach it to take actions in the world based on what it finds.</a:t>
+                  <a:srgbClr val="7A6B78"/>
+                </a:solidFill>
+                <a:latin typeface="Calibri" pitchFamily="34" charset="0"/>
+                <a:ea typeface="Calibri" pitchFamily="34" charset="-122"/>
+                <a:cs typeface="Calibri" pitchFamily="34" charset="-120"/>
+              </a:rPr>
+              <a:t>You spent this week teaching a model to find and use the right information, even scattered across documents that don't agree on formatting. Next week, you'll teach it to take actions based on what it finds.</a:t>
             </a:r>
             <a:endParaRPr lang="en-US" sz="1300" dirty="0"/>
           </a:p>
@@ -2722,7 +2722,7 @@
             <a:r>
               <a:rPr lang="en-US" sz="1000" dirty="0">
                 <a:solidFill>
-                  <a:srgbClr val="6B7280"/>
+                  <a:srgbClr val="7A6B78"/>
                 </a:solidFill>
                 <a:latin typeface="Calibri" pitchFamily="34" charset="0"/>
                 <a:ea typeface="Calibri" pitchFamily="34" charset="-122"/>
@@ -2761,7 +2761,7 @@
             <a:r>
               <a:rPr lang="en-US" sz="1000" dirty="0">
                 <a:solidFill>
-                  <a:srgbClr val="6B7280"/>
+                  <a:srgbClr val="7A6B78"/>
                 </a:solidFill>
                 <a:latin typeface="Calibri" pitchFamily="34" charset="0"/>
                 <a:ea typeface="Calibri" pitchFamily="34" charset="-122"/>
@@ -2832,7 +2832,7 @@
             <a:r>
               <a:rPr lang="en-US" sz="2800" b="1" dirty="0">
                 <a:solidFill>
-                  <a:srgbClr val="232B45"/>
+                  <a:srgbClr val="2B1A2E"/>
                 </a:solidFill>
                 <a:latin typeface="Cambria" pitchFamily="34" charset="0"/>
                 <a:ea typeface="Cambria" pitchFamily="34" charset="-122"/>
@@ -2861,7 +2861,7 @@
             </a:avLst>
           </a:prstGeom>
           <a:solidFill>
-            <a:srgbClr val="F4F6FB"/>
+            <a:srgbClr val="FBF3E7"/>
           </a:solidFill>
           <a:ln/>
           <a:effectLst>
@@ -2900,7 +2900,7 @@
             <a:r>
               <a:rPr lang="en-US" sz="2000" b="1" dirty="0">
                 <a:solidFill>
-                  <a:srgbClr val="FF6B6B"/>
+                  <a:srgbClr val="C45B6E"/>
                 </a:solidFill>
                 <a:latin typeface="Cambria" pitchFamily="34" charset="0"/>
                 <a:ea typeface="Cambria" pitchFamily="34" charset="-122"/>
@@ -2939,7 +2939,7 @@
             <a:r>
               <a:rPr lang="en-US" sz="1400" b="1" dirty="0">
                 <a:solidFill>
-                  <a:srgbClr val="232B45"/>
+                  <a:srgbClr val="2B1A2E"/>
                 </a:solidFill>
                 <a:latin typeface="Calibri" pitchFamily="34" charset="0"/>
                 <a:ea typeface="Calibri" pitchFamily="34" charset="-122"/>
@@ -2981,7 +2981,7 @@
             <a:r>
               <a:rPr lang="en-US" sz="1150" dirty="0">
                 <a:solidFill>
-                  <a:srgbClr val="6B7280"/>
+                  <a:srgbClr val="7A6B78"/>
                 </a:solidFill>
                 <a:latin typeface="Calibri" pitchFamily="34" charset="0"/>
                 <a:ea typeface="Calibri" pitchFamily="34" charset="-122"/>
@@ -3010,7 +3010,7 @@
             </a:avLst>
           </a:prstGeom>
           <a:solidFill>
-            <a:srgbClr val="F4F6FB"/>
+            <a:srgbClr val="FBF3E7"/>
           </a:solidFill>
           <a:ln/>
           <a:effectLst>
@@ -3049,7 +3049,7 @@
             <a:r>
               <a:rPr lang="en-US" sz="2000" b="1" dirty="0">
                 <a:solidFill>
-                  <a:srgbClr val="FF6B6B"/>
+                  <a:srgbClr val="C45B6E"/>
                 </a:solidFill>
                 <a:latin typeface="Cambria" pitchFamily="34" charset="0"/>
                 <a:ea typeface="Cambria" pitchFamily="34" charset="-122"/>
@@ -3088,7 +3088,7 @@
             <a:r>
               <a:rPr lang="en-US" sz="1400" b="1" dirty="0">
                 <a:solidFill>
-                  <a:srgbClr val="232B45"/>
+                  <a:srgbClr val="2B1A2E"/>
                 </a:solidFill>
                 <a:latin typeface="Calibri" pitchFamily="34" charset="0"/>
                 <a:ea typeface="Calibri" pitchFamily="34" charset="-122"/>
@@ -3130,7 +3130,7 @@
             <a:r>
               <a:rPr lang="en-US" sz="1150" dirty="0">
                 <a:solidFill>
-                  <a:srgbClr val="6B7280"/>
+                  <a:srgbClr val="7A6B78"/>
                 </a:solidFill>
                 <a:latin typeface="Calibri" pitchFamily="34" charset="0"/>
                 <a:ea typeface="Calibri" pitchFamily="34" charset="-122"/>
@@ -3159,7 +3159,7 @@
             </a:avLst>
           </a:prstGeom>
           <a:solidFill>
-            <a:srgbClr val="F4F6FB"/>
+            <a:srgbClr val="FBF3E7"/>
           </a:solidFill>
           <a:ln/>
           <a:effectLst>
@@ -3198,7 +3198,7 @@
             <a:r>
               <a:rPr lang="en-US" sz="2000" b="1" dirty="0">
                 <a:solidFill>
-                  <a:srgbClr val="FF6B6B"/>
+                  <a:srgbClr val="C45B6E"/>
                 </a:solidFill>
                 <a:latin typeface="Cambria" pitchFamily="34" charset="0"/>
                 <a:ea typeface="Cambria" pitchFamily="34" charset="-122"/>
@@ -3237,7 +3237,7 @@
             <a:r>
               <a:rPr lang="en-US" sz="1400" b="1" dirty="0">
                 <a:solidFill>
-                  <a:srgbClr val="232B45"/>
+                  <a:srgbClr val="2B1A2E"/>
                 </a:solidFill>
                 <a:latin typeface="Calibri" pitchFamily="34" charset="0"/>
                 <a:ea typeface="Calibri" pitchFamily="34" charset="-122"/>
@@ -3279,7 +3279,7 @@
             <a:r>
               <a:rPr lang="en-US" sz="1150" dirty="0">
                 <a:solidFill>
-                  <a:srgbClr val="6B7280"/>
+                  <a:srgbClr val="7A6B78"/>
                 </a:solidFill>
                 <a:latin typeface="Calibri" pitchFamily="34" charset="0"/>
                 <a:ea typeface="Calibri" pitchFamily="34" charset="-122"/>
@@ -3308,7 +3308,7 @@
             </a:avLst>
           </a:prstGeom>
           <a:solidFill>
-            <a:srgbClr val="F4F6FB"/>
+            <a:srgbClr val="FBF3E7"/>
           </a:solidFill>
           <a:ln/>
           <a:effectLst>
@@ -3347,7 +3347,7 @@
             <a:r>
               <a:rPr lang="en-US" sz="2000" b="1" dirty="0">
                 <a:solidFill>
-                  <a:srgbClr val="FF6B6B"/>
+                  <a:srgbClr val="C45B6E"/>
                 </a:solidFill>
                 <a:latin typeface="Cambria" pitchFamily="34" charset="0"/>
                 <a:ea typeface="Cambria" pitchFamily="34" charset="-122"/>
@@ -3386,7 +3386,7 @@
             <a:r>
               <a:rPr lang="en-US" sz="1400" b="1" dirty="0">
                 <a:solidFill>
-                  <a:srgbClr val="232B45"/>
+                  <a:srgbClr val="2B1A2E"/>
                 </a:solidFill>
                 <a:latin typeface="Calibri" pitchFamily="34" charset="0"/>
                 <a:ea typeface="Calibri" pitchFamily="34" charset="-122"/>
@@ -3428,7 +3428,7 @@
             <a:r>
               <a:rPr lang="en-US" sz="1150" dirty="0">
                 <a:solidFill>
-                  <a:srgbClr val="6B7280"/>
+                  <a:srgbClr val="7A6B78"/>
                 </a:solidFill>
                 <a:latin typeface="Calibri" pitchFamily="34" charset="0"/>
                 <a:ea typeface="Calibri" pitchFamily="34" charset="-122"/>
@@ -3457,7 +3457,7 @@
             </a:avLst>
           </a:prstGeom>
           <a:solidFill>
-            <a:srgbClr val="CADCFC"/>
+            <a:srgbClr val="F7F1F4"/>
           </a:solidFill>
           <a:ln/>
           <a:effectLst>
@@ -3496,7 +3496,7 @@
             <a:r>
               <a:rPr lang="en-US" sz="2000" b="1" dirty="0">
                 <a:solidFill>
-                  <a:srgbClr val="FF6B6B"/>
+                  <a:srgbClr val="C45B6E"/>
                 </a:solidFill>
                 <a:latin typeface="Cambria" pitchFamily="34" charset="0"/>
                 <a:ea typeface="Cambria" pitchFamily="34" charset="-122"/>
@@ -3535,7 +3535,7 @@
             <a:r>
               <a:rPr lang="en-US" sz="1400" b="1" dirty="0">
                 <a:solidFill>
-                  <a:srgbClr val="232B45"/>
+                  <a:srgbClr val="2B1A2E"/>
                 </a:solidFill>
                 <a:latin typeface="Calibri" pitchFamily="34" charset="0"/>
                 <a:ea typeface="Calibri" pitchFamily="34" charset="-122"/>
@@ -3577,7 +3577,7 @@
             <a:r>
               <a:rPr lang="en-US" sz="1150" dirty="0">
                 <a:solidFill>
-                  <a:srgbClr val="6B7280"/>
+                  <a:srgbClr val="7A6B78"/>
                 </a:solidFill>
                 <a:latin typeface="Calibri" pitchFamily="34" charset="0"/>
                 <a:ea typeface="Calibri" pitchFamily="34" charset="-122"/>
@@ -3606,7 +3606,7 @@
             </a:avLst>
           </a:prstGeom>
           <a:solidFill>
-            <a:srgbClr val="1E2761"/>
+            <a:srgbClr val="4A2545"/>
           </a:solidFill>
           <a:ln/>
           <a:effectLst>
@@ -3633,7 +3633,7 @@
             <a:avLst/>
           </a:prstGeom>
           <a:solidFill>
-            <a:srgbClr val="FF6B6B"/>
+            <a:srgbClr val="E8B339"/>
           </a:solidFill>
           <a:ln/>
         </p:spPr>
@@ -3698,7 +3698,7 @@
                 <a:ea typeface="Calibri" pitchFamily="34" charset="-122"/>
                 <a:cs typeface="Calibri" pitchFamily="34" charset="-120"/>
               </a:rPr>
-              <a:t>Today (3.6) doesn't introduce a new concept. It puts all five pieces together into one realistic system — and realistic systems reveal problems that tidy single-document examples hide.</a:t>
+              <a:t>Today (3.6) doesn't introduce a new concept. It puts all five pieces together over four real, overlapping campus documents — and overlap reveals problems a tidy single-document example hides.</a:t>
             </a:r>
             <a:endParaRPr lang="en-US" sz="1550" dirty="0"/>
           </a:p>
@@ -3731,7 +3731,7 @@
             <a:r>
               <a:rPr lang="en-US" sz="1000" dirty="0">
                 <a:solidFill>
-                  <a:srgbClr val="6B7280"/>
+                  <a:srgbClr val="7A6B78"/>
                 </a:solidFill>
                 <a:latin typeface="Calibri" pitchFamily="34" charset="0"/>
                 <a:ea typeface="Calibri" pitchFamily="34" charset="-122"/>
@@ -3770,7 +3770,7 @@
             <a:r>
               <a:rPr lang="en-US" sz="1000" dirty="0">
                 <a:solidFill>
-                  <a:srgbClr val="6B7280"/>
+                  <a:srgbClr val="7A6B78"/>
                 </a:solidFill>
                 <a:latin typeface="Calibri" pitchFamily="34" charset="0"/>
                 <a:ea typeface="Calibri" pitchFamily="34" charset="-122"/>
@@ -3841,13 +3841,13 @@
             <a:r>
               <a:rPr lang="en-US" sz="2800" b="1" dirty="0">
                 <a:solidFill>
-                  <a:srgbClr val="232B45"/>
+                  <a:srgbClr val="2B1A2E"/>
                 </a:solidFill>
                 <a:latin typeface="Cambria" pitchFamily="34" charset="0"/>
                 <a:ea typeface="Cambria" pitchFamily="34" charset="-122"/>
                 <a:cs typeface="Cambria" pitchFamily="34" charset="-120"/>
               </a:rPr>
-              <a:t>One handbook vs. four real policy documents</a:t>
+              <a:t>Today's corpus: four campus documents that overlap</a:t>
             </a:r>
             <a:endParaRPr lang="en-US" sz="2800" dirty="0"/>
           </a:p>
@@ -3861,16 +3861,16 @@
         </p:nvSpPr>
         <p:spPr>
           <a:xfrm>
-            <a:off x="640080" y="1371600"/>
-            <a:ext cx="5212080" cy="4480560"/>
+            <a:off x="640080" y="1417320"/>
+            <a:ext cx="5212080" cy="1965960"/>
           </a:xfrm>
           <a:prstGeom prst="roundRect">
             <a:avLst>
-              <a:gd name="adj" fmla="val 2041"/>
+              <a:gd name="adj" fmla="val 4651"/>
             </a:avLst>
           </a:prstGeom>
           <a:solidFill>
-            <a:srgbClr val="F4F6FB"/>
+            <a:srgbClr val="F7F1F4"/>
           </a:solidFill>
           <a:ln/>
           <a:effectLst>
@@ -3890,21 +3890,21 @@
         </p:nvSpPr>
         <p:spPr>
           <a:xfrm>
-            <a:off x="914400" y="1645920"/>
-            <a:ext cx="640080" cy="640080"/>
+            <a:off x="914400" y="1691640"/>
+            <a:ext cx="777240" cy="777240"/>
           </a:xfrm>
           <a:prstGeom prst="ellipse">
             <a:avLst/>
           </a:prstGeom>
           <a:solidFill>
-            <a:srgbClr val="6B7280"/>
+            <a:srgbClr val="C45B6E"/>
           </a:solidFill>
           <a:ln/>
         </p:spPr>
       </p:sp>
       <p:pic>
         <p:nvPicPr>
-          <p:cNvPr id="5" name="Image 0" descr="icon_file_white.png">    </p:cNvPr>
+          <p:cNvPr id="5" name="Image 0" descr="icon_clipboard_white.png">    </p:cNvPr>
           <p:cNvPicPr>
             <a:picLocks noChangeAspect="1"/>
           </p:cNvPicPr>
@@ -3918,8 +3918,8 @@
         </p:blipFill>
         <p:spPr>
           <a:xfrm>
-            <a:off x="1058418" y="1789938"/>
-            <a:ext cx="352044" cy="352044"/>
+            <a:off x="1108710" y="1885950"/>
+            <a:ext cx="388620" cy="388620"/>
           </a:xfrm>
           <a:prstGeom prst="rect">
             <a:avLst/>
@@ -3934,8 +3934,8 @@
         </p:nvSpPr>
         <p:spPr>
           <a:xfrm>
-            <a:off x="1691640" y="1645920"/>
-            <a:ext cx="4023360" cy="640080"/>
+            <a:off x="1874520" y="1691640"/>
+            <a:ext cx="3749040" cy="502920"/>
           </a:xfrm>
           <a:prstGeom prst="rect">
             <a:avLst/>
@@ -3953,13 +3953,13 @@
             <a:r>
               <a:rPr lang="en-US" sz="1600" b="1" dirty="0">
                 <a:solidFill>
-                  <a:srgbClr val="232B45"/>
-                </a:solidFill>
-                <a:latin typeface="Calibri" pitchFamily="34" charset="0"/>
-                <a:ea typeface="Calibri" pitchFamily="34" charset="-122"/>
-                <a:cs typeface="Calibri" pitchFamily="34" charset="-120"/>
-              </a:rPr>
-              <a:t>Sessions 3.3 / 3.4</a:t>
+                  <a:srgbClr val="2B1A2E"/>
+                </a:solidFill>
+                <a:latin typeface="Calibri" pitchFamily="34" charset="0"/>
+                <a:ea typeface="Calibri" pitchFamily="34" charset="-122"/>
+                <a:cs typeface="Calibri" pitchFamily="34" charset="-120"/>
+              </a:rPr>
+              <a:t>Registration Guide</a:t>
             </a:r>
             <a:endParaRPr lang="en-US" sz="1600" dirty="0"/>
           </a:p>
@@ -3973,66 +3973,37 @@
         </p:nvSpPr>
         <p:spPr>
           <a:xfrm>
-            <a:off x="1005840" y="2468880"/>
-            <a:ext cx="4480560" cy="3108960"/>
-          </a:xfrm>
-          <a:prstGeom prst="rect">
-            <a:avLst/>
-          </a:prstGeom>
-          <a:noFill/>
-          <a:ln/>
-        </p:spPr>
-        <p:txBody>
-          <a:bodyPr wrap="square" rtlCol="0" anchor="ctr"/>
+            <a:off x="1874520" y="2286000"/>
+            <a:ext cx="3794760" cy="914400"/>
+          </a:xfrm>
+          <a:prstGeom prst="rect">
+            <a:avLst/>
+          </a:prstGeom>
+          <a:noFill/>
+          <a:ln/>
+        </p:spPr>
+        <p:txBody>
+          <a:bodyPr wrap="square" rtlCol="0" anchor="t"/>
           <a:lstStyle/>
           <a:p>
             <a:pPr indent="0" marL="0">
               <a:lnSpc>
-                <a:spcPct val="140000"/>
+                <a:spcPct val="130000"/>
               </a:lnSpc>
               <a:buNone/>
             </a:pPr>
             <a:r>
-              <a:rPr lang="en-US" sz="1450" dirty="0">
-                <a:solidFill>
-                  <a:srgbClr val="232B45"/>
-                </a:solidFill>
-                <a:latin typeface="Calibri" pitchFamily="34" charset="0"/>
-                <a:ea typeface="Calibri" pitchFamily="34" charset="-122"/>
-                <a:cs typeface="Calibri" pitchFamily="34" charset="-120"/>
-              </a:rPr>
-              <a:t>One self-contained handbook.</a:t>
-            </a:r>
-            <a:endParaRPr lang="en-US" sz="1450" dirty="0"/>
-          </a:p>
-          <a:p>
-            <a:pPr indent="0" marL="0">
-              <a:lnSpc>
-                <a:spcPct val="140000"/>
-              </a:lnSpc>
-              <a:buNone/>
-            </a:pPr>
-            <a:endParaRPr lang="en-US" sz="1450" dirty="0"/>
-          </a:p>
-          <a:p>
-            <a:pPr indent="0" marL="0">
-              <a:lnSpc>
-                <a:spcPct val="140000"/>
-              </a:lnSpc>
-              <a:buNone/>
-            </a:pPr>
-            <a:r>
-              <a:rPr lang="en-US" sz="1450" dirty="0">
-                <a:solidFill>
-                  <a:srgbClr val="232B45"/>
-                </a:solidFill>
-                <a:latin typeface="Calibri" pitchFamily="34" charset="0"/>
-                <a:ea typeface="Calibri" pitchFamily="34" charset="-122"/>
-                <a:cs typeface="Calibri" pitchFamily="34" charset="-120"/>
-              </a:rPr>
-              <a:t>Every retrieved chunk is at least from "the right place," by definition. The worst case is an imprecise chunk — not the wrong source entirely.</a:t>
-            </a:r>
-            <a:endParaRPr lang="en-US" sz="1450" dirty="0"/>
+              <a:rPr lang="en-US" sz="1300" i="1" dirty="0">
+                <a:solidFill>
+                  <a:srgbClr val="7A6B78"/>
+                </a:solidFill>
+                <a:latin typeface="Calibri" pitchFamily="34" charset="0"/>
+                <a:ea typeface="Calibri" pitchFamily="34" charset="-122"/>
+                <a:cs typeface="Calibri" pitchFamily="34" charset="-120"/>
+              </a:rPr>
+              <a:t>Add/drop deadlines, course load limits</a:t>
+            </a:r>
+            <a:endParaRPr lang="en-US" sz="1300" dirty="0"/>
           </a:p>
         </p:txBody>
       </p:sp>
@@ -4044,16 +4015,16 @@
         </p:nvSpPr>
         <p:spPr>
           <a:xfrm>
-            <a:off x="6263640" y="1371600"/>
-            <a:ext cx="5212080" cy="4480560"/>
+            <a:off x="6217920" y="1417320"/>
+            <a:ext cx="5212080" cy="1965960"/>
           </a:xfrm>
           <a:prstGeom prst="roundRect">
             <a:avLst>
-              <a:gd name="adj" fmla="val 2041"/>
+              <a:gd name="adj" fmla="val 4651"/>
             </a:avLst>
           </a:prstGeom>
           <a:solidFill>
-            <a:srgbClr val="1E2761"/>
+            <a:srgbClr val="F7F1F4"/>
           </a:solidFill>
           <a:ln/>
           <a:effectLst>
@@ -4073,21 +4044,21 @@
         </p:nvSpPr>
         <p:spPr>
           <a:xfrm>
-            <a:off x="6537960" y="1645920"/>
-            <a:ext cx="640080" cy="640080"/>
+            <a:off x="6492240" y="1691640"/>
+            <a:ext cx="777240" cy="777240"/>
           </a:xfrm>
           <a:prstGeom prst="ellipse">
             <a:avLst/>
           </a:prstGeom>
           <a:solidFill>
-            <a:srgbClr val="FF6B6B"/>
+            <a:srgbClr val="E8B339"/>
           </a:solidFill>
           <a:ln/>
         </p:spPr>
       </p:sp>
       <p:pic>
         <p:nvPicPr>
-          <p:cNvPr id="10" name="Image 1" descr="icon_diagram_white.png">    </p:cNvPr>
+          <p:cNvPr id="10" name="Image 1" descr="icon_money_white.png">    </p:cNvPr>
           <p:cNvPicPr>
             <a:picLocks noChangeAspect="1"/>
           </p:cNvPicPr>
@@ -4101,8 +4072,8 @@
         </p:blipFill>
         <p:spPr>
           <a:xfrm>
-            <a:off x="6681978" y="1789938"/>
-            <a:ext cx="352044" cy="352044"/>
+            <a:off x="6686550" y="1885950"/>
+            <a:ext cx="388620" cy="388620"/>
           </a:xfrm>
           <a:prstGeom prst="rect">
             <a:avLst/>
@@ -4117,8 +4088,8 @@
         </p:nvSpPr>
         <p:spPr>
           <a:xfrm>
-            <a:off x="7315200" y="1645920"/>
-            <a:ext cx="4023360" cy="640080"/>
+            <a:off x="7452360" y="1691640"/>
+            <a:ext cx="3749040" cy="502920"/>
           </a:xfrm>
           <a:prstGeom prst="rect">
             <a:avLst/>
@@ -4136,13 +4107,13 @@
             <a:r>
               <a:rPr lang="en-US" sz="1600" b="1" dirty="0">
                 <a:solidFill>
-                  <a:srgbClr val="FFFFFF"/>
-                </a:solidFill>
-                <a:latin typeface="Calibri" pitchFamily="34" charset="0"/>
-                <a:ea typeface="Calibri" pitchFamily="34" charset="-122"/>
-                <a:cs typeface="Calibri" pitchFamily="34" charset="-120"/>
-              </a:rPr>
-              <a:t>Session 3.6 — today</a:t>
+                  <a:srgbClr val="2B1A2E"/>
+                </a:solidFill>
+                <a:latin typeface="Calibri" pitchFamily="34" charset="0"/>
+                <a:ea typeface="Calibri" pitchFamily="34" charset="-122"/>
+                <a:cs typeface="Calibri" pitchFamily="34" charset="-120"/>
+              </a:rPr>
+              <a:t>Financial Aid Handbook</a:t>
             </a:r>
             <a:endParaRPr lang="en-US" sz="1600" dirty="0"/>
           </a:p>
@@ -4156,72 +4127,351 @@
         </p:nvSpPr>
         <p:spPr>
           <a:xfrm>
-            <a:off x="6629400" y="2468880"/>
-            <a:ext cx="4480560" cy="3108960"/>
-          </a:xfrm>
-          <a:prstGeom prst="rect">
-            <a:avLst/>
-          </a:prstGeom>
-          <a:noFill/>
-          <a:ln/>
-        </p:spPr>
-        <p:txBody>
-          <a:bodyPr wrap="square" rtlCol="0" anchor="ctr"/>
+            <a:off x="7452360" y="2286000"/>
+            <a:ext cx="3794760" cy="914400"/>
+          </a:xfrm>
+          <a:prstGeom prst="rect">
+            <a:avLst/>
+          </a:prstGeom>
+          <a:noFill/>
+          <a:ln/>
+        </p:spPr>
+        <p:txBody>
+          <a:bodyPr wrap="square" rtlCol="0" anchor="t"/>
           <a:lstStyle/>
           <a:p>
             <a:pPr indent="0" marL="0">
               <a:lnSpc>
-                <a:spcPct val="140000"/>
+                <a:spcPct val="130000"/>
               </a:lnSpc>
               <a:buNone/>
             </a:pPr>
             <a:r>
-              <a:rPr lang="en-US" sz="1450" dirty="0">
-                <a:solidFill>
-                  <a:srgbClr val="FFFFFF"/>
-                </a:solidFill>
-                <a:latin typeface="Calibri" pitchFamily="34" charset="0"/>
-                <a:ea typeface="Calibri" pitchFamily="34" charset="-122"/>
-                <a:cs typeface="Calibri" pitchFamily="34" charset="-120"/>
-              </a:rPr>
-              <a:t>Four separate documents, written by different teams, on different schedules, that overlap and cross-reference each other.</a:t>
-            </a:r>
-            <a:endParaRPr lang="en-US" sz="1450" dirty="0"/>
-          </a:p>
+              <a:rPr lang="en-US" sz="1300" i="1" dirty="0">
+                <a:solidFill>
+                  <a:srgbClr val="7A6B78"/>
+                </a:solidFill>
+                <a:latin typeface="Calibri" pitchFamily="34" charset="0"/>
+                <a:ea typeface="Calibri" pitchFamily="34" charset="-122"/>
+                <a:cs typeface="Calibri" pitchFamily="34" charset="-120"/>
+              </a:rPr>
+              <a:t>Disbursement timing, refunds, work-study</a:t>
+            </a:r>
+            <a:endParaRPr lang="en-US" sz="1300" dirty="0"/>
+          </a:p>
+        </p:txBody>
+      </p:sp>
+      <p:sp>
+        <p:nvSpPr>
+          <p:cNvPr id="13" name="Shape 9"/>
+          <p:cNvSpPr/>
+          <p:nvPr/>
+        </p:nvSpPr>
+        <p:spPr>
+          <a:xfrm>
+            <a:off x="640080" y="3657600"/>
+            <a:ext cx="5212080" cy="1965960"/>
+          </a:xfrm>
+          <a:prstGeom prst="roundRect">
+            <a:avLst>
+              <a:gd name="adj" fmla="val 4651"/>
+            </a:avLst>
+          </a:prstGeom>
+          <a:solidFill>
+            <a:srgbClr val="F7F1F4"/>
+          </a:solidFill>
+          <a:ln/>
+          <a:effectLst>
+            <a:outerShdw sx="100000" sy="100000" kx="0" ky="0" algn="bl" rotWithShape="0" blurRad="101600" dist="38100" dir="2700000">
+              <a:srgbClr val="000000">
+                <a:alpha val="12000"/>
+              </a:srgbClr>
+            </a:outerShdw>
+          </a:effectLst>
+        </p:spPr>
+      </p:sp>
+      <p:sp>
+        <p:nvSpPr>
+          <p:cNvPr id="14" name="Shape 10"/>
+          <p:cNvSpPr/>
+          <p:nvPr/>
+        </p:nvSpPr>
+        <p:spPr>
+          <a:xfrm>
+            <a:off x="914400" y="3931920"/>
+            <a:ext cx="777240" cy="777240"/>
+          </a:xfrm>
+          <a:prstGeom prst="ellipse">
+            <a:avLst/>
+          </a:prstGeom>
+          <a:solidFill>
+            <a:srgbClr val="4A2545"/>
+          </a:solidFill>
+          <a:ln/>
+        </p:spPr>
+      </p:sp>
+      <p:pic>
+        <p:nvPicPr>
+          <p:cNvPr id="15" name="Image 2" descr="icon_usergrad_white.png">    </p:cNvPr>
+          <p:cNvPicPr>
+            <a:picLocks noChangeAspect="1"/>
+          </p:cNvPicPr>
+          <p:nvPr/>
+        </p:nvPicPr>
+        <p:blipFill>
+          <a:blip r:embed="rId3"/>
+          <a:stretch>
+            <a:fillRect/>
+          </a:stretch>
+        </p:blipFill>
+        <p:spPr>
+          <a:xfrm>
+            <a:off x="1108710" y="4126230"/>
+            <a:ext cx="388620" cy="388620"/>
+          </a:xfrm>
+          <a:prstGeom prst="rect">
+            <a:avLst/>
+          </a:prstGeom>
+        </p:spPr>
+      </p:pic>
+      <p:sp>
+        <p:nvSpPr>
+          <p:cNvPr id="16" name="Text 11"/>
+          <p:cNvSpPr/>
+          <p:nvPr/>
+        </p:nvSpPr>
+        <p:spPr>
+          <a:xfrm>
+            <a:off x="1874520" y="3931920"/>
+            <a:ext cx="3749040" cy="502920"/>
+          </a:xfrm>
+          <a:prstGeom prst="rect">
+            <a:avLst/>
+          </a:prstGeom>
+          <a:noFill/>
+          <a:ln/>
+        </p:spPr>
+        <p:txBody>
+          <a:bodyPr wrap="square" rtlCol="0" anchor="ctr"/>
+          <a:lstStyle/>
+          <a:p>
+            <a:pPr indent="0" marL="0">
+              <a:buNone/>
+            </a:pPr>
+            <a:r>
+              <a:rPr lang="en-US" sz="1600" b="1" dirty="0">
+                <a:solidFill>
+                  <a:srgbClr val="2B1A2E"/>
+                </a:solidFill>
+                <a:latin typeface="Calibri" pitchFamily="34" charset="0"/>
+                <a:ea typeface="Calibri" pitchFamily="34" charset="-122"/>
+                <a:cs typeface="Calibri" pitchFamily="34" charset="-120"/>
+              </a:rPr>
+              <a:t>Academic Standing Policy</a:t>
+            </a:r>
+            <a:endParaRPr lang="en-US" sz="1600" dirty="0"/>
+          </a:p>
+        </p:txBody>
+      </p:sp>
+      <p:sp>
+        <p:nvSpPr>
+          <p:cNvPr id="17" name="Text 12"/>
+          <p:cNvSpPr/>
+          <p:nvPr/>
+        </p:nvSpPr>
+        <p:spPr>
+          <a:xfrm>
+            <a:off x="1874520" y="4526280"/>
+            <a:ext cx="3794760" cy="914400"/>
+          </a:xfrm>
+          <a:prstGeom prst="rect">
+            <a:avLst/>
+          </a:prstGeom>
+          <a:noFill/>
+          <a:ln/>
+        </p:spPr>
+        <p:txBody>
+          <a:bodyPr wrap="square" rtlCol="0" anchor="t"/>
+          <a:lstStyle/>
           <a:p>
             <a:pPr indent="0" marL="0">
               <a:lnSpc>
-                <a:spcPct val="140000"/>
+                <a:spcPct val="130000"/>
               </a:lnSpc>
               <a:buNone/>
             </a:pPr>
-            <a:endParaRPr lang="en-US" sz="1450" dirty="0"/>
-          </a:p>
+            <a:r>
+              <a:rPr lang="en-US" sz="1300" i="1" dirty="0">
+                <a:solidFill>
+                  <a:srgbClr val="7A6B78"/>
+                </a:solidFill>
+                <a:latin typeface="Calibri" pitchFamily="34" charset="0"/>
+                <a:ea typeface="Calibri" pitchFamily="34" charset="-122"/>
+                <a:cs typeface="Calibri" pitchFamily="34" charset="-120"/>
+              </a:rPr>
+              <a:t>GPA thresholds, probation: max 13 credits</a:t>
+            </a:r>
+            <a:endParaRPr lang="en-US" sz="1300" dirty="0"/>
+          </a:p>
+        </p:txBody>
+      </p:sp>
+      <p:sp>
+        <p:nvSpPr>
+          <p:cNvPr id="18" name="Shape 13"/>
+          <p:cNvSpPr/>
+          <p:nvPr/>
+        </p:nvSpPr>
+        <p:spPr>
+          <a:xfrm>
+            <a:off x="6217920" y="3657600"/>
+            <a:ext cx="5212080" cy="1965960"/>
+          </a:xfrm>
+          <a:prstGeom prst="roundRect">
+            <a:avLst>
+              <a:gd name="adj" fmla="val 4651"/>
+            </a:avLst>
+          </a:prstGeom>
+          <a:solidFill>
+            <a:srgbClr val="F7F1F4"/>
+          </a:solidFill>
+          <a:ln/>
+          <a:effectLst>
+            <a:outerShdw sx="100000" sy="100000" kx="0" ky="0" algn="bl" rotWithShape="0" blurRad="101600" dist="38100" dir="2700000">
+              <a:srgbClr val="000000">
+                <a:alpha val="12000"/>
+              </a:srgbClr>
+            </a:outerShdw>
+          </a:effectLst>
+        </p:spPr>
+      </p:sp>
+      <p:sp>
+        <p:nvSpPr>
+          <p:cNvPr id="19" name="Shape 14"/>
+          <p:cNvSpPr/>
+          <p:nvPr/>
+        </p:nvSpPr>
+        <p:spPr>
+          <a:xfrm>
+            <a:off x="6492240" y="3931920"/>
+            <a:ext cx="777240" cy="777240"/>
+          </a:xfrm>
+          <a:prstGeom prst="ellipse">
+            <a:avLst/>
+          </a:prstGeom>
+          <a:solidFill>
+            <a:srgbClr val="7A6B78"/>
+          </a:solidFill>
+          <a:ln/>
+        </p:spPr>
+      </p:sp>
+      <p:pic>
+        <p:nvPicPr>
+          <p:cNvPr id="20" name="Image 3" descr="icon_bed_white.png">    </p:cNvPr>
+          <p:cNvPicPr>
+            <a:picLocks noChangeAspect="1"/>
+          </p:cNvPicPr>
+          <p:nvPr/>
+        </p:nvPicPr>
+        <p:blipFill>
+          <a:blip r:embed="rId4"/>
+          <a:stretch>
+            <a:fillRect/>
+          </a:stretch>
+        </p:blipFill>
+        <p:spPr>
+          <a:xfrm>
+            <a:off x="6686550" y="4126230"/>
+            <a:ext cx="388620" cy="388620"/>
+          </a:xfrm>
+          <a:prstGeom prst="rect">
+            <a:avLst/>
+          </a:prstGeom>
+        </p:spPr>
+      </p:pic>
+      <p:sp>
+        <p:nvSpPr>
+          <p:cNvPr id="21" name="Text 15"/>
+          <p:cNvSpPr/>
+          <p:nvPr/>
+        </p:nvSpPr>
+        <p:spPr>
+          <a:xfrm>
+            <a:off x="7452360" y="3931920"/>
+            <a:ext cx="3749040" cy="502920"/>
+          </a:xfrm>
+          <a:prstGeom prst="rect">
+            <a:avLst/>
+          </a:prstGeom>
+          <a:noFill/>
+          <a:ln/>
+        </p:spPr>
+        <p:txBody>
+          <a:bodyPr wrap="square" rtlCol="0" anchor="ctr"/>
+          <a:lstStyle/>
+          <a:p>
+            <a:pPr indent="0" marL="0">
+              <a:buNone/>
+            </a:pPr>
+            <a:r>
+              <a:rPr lang="en-US" sz="1600" b="1" dirty="0">
+                <a:solidFill>
+                  <a:srgbClr val="2B1A2E"/>
+                </a:solidFill>
+                <a:latin typeface="Calibri" pitchFamily="34" charset="0"/>
+                <a:ea typeface="Calibri" pitchFamily="34" charset="-122"/>
+                <a:cs typeface="Calibri" pitchFamily="34" charset="-120"/>
+              </a:rPr>
+              <a:t>Housing Handbook</a:t>
+            </a:r>
+            <a:endParaRPr lang="en-US" sz="1600" dirty="0"/>
+          </a:p>
+        </p:txBody>
+      </p:sp>
+      <p:sp>
+        <p:nvSpPr>
+          <p:cNvPr id="22" name="Text 16"/>
+          <p:cNvSpPr/>
+          <p:nvPr/>
+        </p:nvSpPr>
+        <p:spPr>
+          <a:xfrm>
+            <a:off x="7452360" y="4526280"/>
+            <a:ext cx="3794760" cy="914400"/>
+          </a:xfrm>
+          <a:prstGeom prst="rect">
+            <a:avLst/>
+          </a:prstGeom>
+          <a:noFill/>
+          <a:ln/>
+        </p:spPr>
+        <p:txBody>
+          <a:bodyPr wrap="square" rtlCol="0" anchor="t"/>
+          <a:lstStyle/>
           <a:p>
             <a:pPr indent="0" marL="0">
               <a:lnSpc>
-                <a:spcPct val="140000"/>
+                <a:spcPct val="130000"/>
               </a:lnSpc>
               <a:buNone/>
             </a:pPr>
             <a:r>
-              <a:rPr lang="en-US" sz="1450" dirty="0">
-                <a:solidFill>
-                  <a:srgbClr val="FFFFFF"/>
-                </a:solidFill>
-                <a:latin typeface="Calibri" pitchFamily="34" charset="0"/>
-                <a:ea typeface="Calibri" pitchFamily="34" charset="-122"/>
-                <a:cs typeface="Calibri" pitchFamily="34" charset="-120"/>
-              </a:rPr>
-              <a:t>Retrieval can now confidently return the WRONG document — a harder, more dangerous failure to spot.</a:t>
-            </a:r>
-            <a:endParaRPr lang="en-US" sz="1450" dirty="0"/>
-          </a:p>
-        </p:txBody>
-      </p:sp>
-      <p:sp>
-        <p:nvSpPr>
-          <p:cNvPr id="13" name="Text 9"/>
+              <a:rPr lang="en-US" sz="1300" i="1" dirty="0">
+                <a:solidFill>
+                  <a:srgbClr val="7A6B78"/>
+                </a:solidFill>
+                <a:latin typeface="Calibri" pitchFamily="34" charset="0"/>
+                <a:ea typeface="Calibri" pitchFamily="34" charset="-122"/>
+                <a:cs typeface="Calibri" pitchFamily="34" charset="-120"/>
+              </a:rPr>
+              <a:t>Dorm assignment, eligibility tied to enrollment</a:t>
+            </a:r>
+            <a:endParaRPr lang="en-US" sz="1300" dirty="0"/>
+          </a:p>
+        </p:txBody>
+      </p:sp>
+      <p:sp>
+        <p:nvSpPr>
+          <p:cNvPr id="23" name="Text 17"/>
           <p:cNvSpPr/>
           <p:nvPr/>
         </p:nvSpPr>
@@ -4246,7 +4496,7 @@
             <a:r>
               <a:rPr lang="en-US" sz="1000" dirty="0">
                 <a:solidFill>
-                  <a:srgbClr val="6B7280"/>
+                  <a:srgbClr val="7A6B78"/>
                 </a:solidFill>
                 <a:latin typeface="Calibri" pitchFamily="34" charset="0"/>
                 <a:ea typeface="Calibri" pitchFamily="34" charset="-122"/>
@@ -4260,7 +4510,7 @@
       </p:sp>
       <p:sp>
         <p:nvSpPr>
-          <p:cNvPr id="14" name="Text 10"/>
+          <p:cNvPr id="24" name="Text 18"/>
           <p:cNvSpPr/>
           <p:nvPr/>
         </p:nvSpPr>
@@ -4285,7 +4535,7 @@
             <a:r>
               <a:rPr lang="en-US" sz="1000" dirty="0">
                 <a:solidFill>
-                  <a:srgbClr val="6B7280"/>
+                  <a:srgbClr val="7A6B78"/>
                 </a:solidFill>
                 <a:latin typeface="Calibri" pitchFamily="34" charset="0"/>
                 <a:ea typeface="Calibri" pitchFamily="34" charset="-122"/>
@@ -4354,17 +4604,17 @@
               <a:buNone/>
             </a:pPr>
             <a:r>
-              <a:rPr lang="en-US" sz="2800" b="1" dirty="0">
-                <a:solidFill>
-                  <a:srgbClr val="232B45"/>
+              <a:rPr lang="en-US" sz="2600" b="1" dirty="0">
+                <a:solidFill>
+                  <a:srgbClr val="2B1A2E"/>
                 </a:solidFill>
                 <a:latin typeface="Cambria" pitchFamily="34" charset="0"/>
                 <a:ea typeface="Cambria" pitchFamily="34" charset="-122"/>
                 <a:cs typeface="Cambria" pitchFamily="34" charset="-120"/>
               </a:rPr>
-              <a:t>Today's corpus: four real-shaped policy PDFs</a:t>
-            </a:r>
-            <a:endParaRPr lang="en-US" sz="2800" dirty="0"/>
+              <a:t>Why documents that cross-reference each other are harder</a:t>
+            </a:r>
+            <a:endParaRPr lang="en-US" sz="2600" dirty="0"/>
           </a:p>
         </p:txBody>
       </p:sp>
@@ -4376,16 +4626,16 @@
         </p:nvSpPr>
         <p:spPr>
           <a:xfrm>
-            <a:off x="640080" y="1417320"/>
-            <a:ext cx="5212080" cy="1965960"/>
+            <a:off x="640080" y="1371600"/>
+            <a:ext cx="5212080" cy="4480560"/>
           </a:xfrm>
           <a:prstGeom prst="roundRect">
             <a:avLst>
-              <a:gd name="adj" fmla="val 4651"/>
+              <a:gd name="adj" fmla="val 2041"/>
             </a:avLst>
           </a:prstGeom>
           <a:solidFill>
-            <a:srgbClr val="F4F6FB"/>
+            <a:srgbClr val="F7F1F4"/>
           </a:solidFill>
           <a:ln/>
           <a:effectLst>
@@ -4405,21 +4655,21 @@
         </p:nvSpPr>
         <p:spPr>
           <a:xfrm>
-            <a:off x="914400" y="1691640"/>
-            <a:ext cx="777240" cy="777240"/>
+            <a:off x="914400" y="1645920"/>
+            <a:ext cx="640080" cy="640080"/>
           </a:xfrm>
           <a:prstGeom prst="ellipse">
             <a:avLst/>
           </a:prstGeom>
           <a:solidFill>
-            <a:srgbClr val="FF6B6B"/>
+            <a:srgbClr val="7A6B78"/>
           </a:solidFill>
           <a:ln/>
         </p:spPr>
       </p:sp>
       <p:pic>
         <p:nvPicPr>
-          <p:cNvPr id="5" name="Image 0" descr="icon_home_white.png">    </p:cNvPr>
+          <p:cNvPr id="5" name="Image 0" descr="icon_grad_white.png">    </p:cNvPr>
           <p:cNvPicPr>
             <a:picLocks noChangeAspect="1"/>
           </p:cNvPicPr>
@@ -4433,8 +4683,8 @@
         </p:blipFill>
         <p:spPr>
           <a:xfrm>
-            <a:off x="1108710" y="1885950"/>
-            <a:ext cx="388620" cy="388620"/>
+            <a:off x="1058418" y="1789938"/>
+            <a:ext cx="352044" cy="352044"/>
           </a:xfrm>
           <a:prstGeom prst="rect">
             <a:avLst/>
@@ -4449,8 +4699,8 @@
         </p:nvSpPr>
         <p:spPr>
           <a:xfrm>
-            <a:off x="1874520" y="1691640"/>
-            <a:ext cx="3749040" cy="502920"/>
+            <a:off x="1691640" y="1645920"/>
+            <a:ext cx="4023360" cy="640080"/>
           </a:xfrm>
           <a:prstGeom prst="rect">
             <a:avLst/>
@@ -4468,13 +4718,13 @@
             <a:r>
               <a:rPr lang="en-US" sz="1600" b="1" dirty="0">
                 <a:solidFill>
-                  <a:srgbClr val="232B45"/>
-                </a:solidFill>
-                <a:latin typeface="Calibri" pitchFamily="34" charset="0"/>
-                <a:ea typeface="Calibri" pitchFamily="34" charset="-122"/>
-                <a:cs typeface="Calibri" pitchFamily="34" charset="-120"/>
-              </a:rPr>
-              <a:t>Remote Work Policy</a:t>
+                  <a:srgbClr val="2B1A2E"/>
+                </a:solidFill>
+                <a:latin typeface="Calibri" pitchFamily="34" charset="0"/>
+                <a:ea typeface="Calibri" pitchFamily="34" charset="-122"/>
+                <a:cs typeface="Calibri" pitchFamily="34" charset="-120"/>
+              </a:rPr>
+              <a:t>Sessions 3.3 / 3.4</a:t>
             </a:r>
             <a:endParaRPr lang="en-US" sz="1600" dirty="0"/>
           </a:p>
@@ -4488,37 +4738,66 @@
         </p:nvSpPr>
         <p:spPr>
           <a:xfrm>
-            <a:off x="1874520" y="2286000"/>
-            <a:ext cx="3794760" cy="914400"/>
-          </a:xfrm>
-          <a:prstGeom prst="rect">
-            <a:avLst/>
-          </a:prstGeom>
-          <a:noFill/>
-          <a:ln/>
-        </p:spPr>
-        <p:txBody>
-          <a:bodyPr wrap="square" rtlCol="0" anchor="t"/>
+            <a:off x="1005840" y="2468880"/>
+            <a:ext cx="4480560" cy="3108960"/>
+          </a:xfrm>
+          <a:prstGeom prst="rect">
+            <a:avLst/>
+          </a:prstGeom>
+          <a:noFill/>
+          <a:ln/>
+        </p:spPr>
+        <p:txBody>
+          <a:bodyPr wrap="square" rtlCol="0" anchor="ctr"/>
           <a:lstStyle/>
           <a:p>
             <a:pPr indent="0" marL="0">
               <a:lnSpc>
-                <a:spcPct val="130000"/>
+                <a:spcPct val="140000"/>
               </a:lnSpc>
               <a:buNone/>
             </a:pPr>
             <a:r>
-              <a:rPr lang="en-US" sz="1300" i="1" dirty="0">
-                <a:solidFill>
-                  <a:srgbClr val="6B7280"/>
-                </a:solidFill>
-                <a:latin typeface="Calibri" pitchFamily="34" charset="0"/>
-                <a:ea typeface="Calibri" pitchFamily="34" charset="-122"/>
-                <a:cs typeface="Calibri" pitchFamily="34" charset="-120"/>
-              </a:rPr>
-              <a:t>Home office stipend: up to $500</a:t>
-            </a:r>
-            <a:endParaRPr lang="en-US" sz="1300" dirty="0"/>
+              <a:rPr lang="en-US" sz="1450" dirty="0">
+                <a:solidFill>
+                  <a:srgbClr val="2B1A2E"/>
+                </a:solidFill>
+                <a:latin typeface="Calibri" pitchFamily="34" charset="0"/>
+                <a:ea typeface="Calibri" pitchFamily="34" charset="-122"/>
+                <a:cs typeface="Calibri" pitchFamily="34" charset="-120"/>
+              </a:rPr>
+              <a:t>One self-contained document.</a:t>
+            </a:r>
+            <a:endParaRPr lang="en-US" sz="1450" dirty="0"/>
+          </a:p>
+          <a:p>
+            <a:pPr indent="0" marL="0">
+              <a:lnSpc>
+                <a:spcPct val="140000"/>
+              </a:lnSpc>
+              <a:buNone/>
+            </a:pPr>
+            <a:endParaRPr lang="en-US" sz="1450" dirty="0"/>
+          </a:p>
+          <a:p>
+            <a:pPr indent="0" marL="0">
+              <a:lnSpc>
+                <a:spcPct val="140000"/>
+              </a:lnSpc>
+              <a:buNone/>
+            </a:pPr>
+            <a:r>
+              <a:rPr lang="en-US" sz="1450" dirty="0">
+                <a:solidFill>
+                  <a:srgbClr val="2B1A2E"/>
+                </a:solidFill>
+                <a:latin typeface="Calibri" pitchFamily="34" charset="0"/>
+                <a:ea typeface="Calibri" pitchFamily="34" charset="-122"/>
+                <a:cs typeface="Calibri" pitchFamily="34" charset="-120"/>
+              </a:rPr>
+              <a:t>Every retrieved chunk is at least from “the right place,” by definition. The worst case is an imprecise chunk — not the wrong source entirely.</a:t>
+            </a:r>
+            <a:endParaRPr lang="en-US" sz="1450" dirty="0"/>
           </a:p>
         </p:txBody>
       </p:sp>
@@ -4530,16 +4809,16 @@
         </p:nvSpPr>
         <p:spPr>
           <a:xfrm>
-            <a:off x="6217920" y="1417320"/>
-            <a:ext cx="5212080" cy="1965960"/>
+            <a:off x="6263640" y="1371600"/>
+            <a:ext cx="5212080" cy="4480560"/>
           </a:xfrm>
           <a:prstGeom prst="roundRect">
             <a:avLst>
-              <a:gd name="adj" fmla="val 4651"/>
+              <a:gd name="adj" fmla="val 2041"/>
             </a:avLst>
           </a:prstGeom>
           <a:solidFill>
-            <a:srgbClr val="F4F6FB"/>
+            <a:srgbClr val="4A2545"/>
           </a:solidFill>
           <a:ln/>
           <a:effectLst>
@@ -4559,21 +4838,21 @@
         </p:nvSpPr>
         <p:spPr>
           <a:xfrm>
-            <a:off x="6492240" y="1691640"/>
-            <a:ext cx="777240" cy="777240"/>
+            <a:off x="6537960" y="1645920"/>
+            <a:ext cx="640080" cy="640080"/>
           </a:xfrm>
           <a:prstGeom prst="ellipse">
             <a:avLst/>
           </a:prstGeom>
           <a:solidFill>
-            <a:srgbClr val="F4B942"/>
+            <a:srgbClr val="E8B339"/>
           </a:solidFill>
           <a:ln/>
         </p:spPr>
       </p:sp>
       <p:pic>
         <p:nvPicPr>
-          <p:cNvPr id="10" name="Image 1" descr="icon_money_white.png">    </p:cNvPr>
+          <p:cNvPr id="10" name="Image 1" descr="icon_diagram_white.png">    </p:cNvPr>
           <p:cNvPicPr>
             <a:picLocks noChangeAspect="1"/>
           </p:cNvPicPr>
@@ -4587,8 +4866,8 @@
         </p:blipFill>
         <p:spPr>
           <a:xfrm>
-            <a:off x="6686550" y="1885950"/>
-            <a:ext cx="388620" cy="388620"/>
+            <a:off x="6681978" y="1789938"/>
+            <a:ext cx="352044" cy="352044"/>
           </a:xfrm>
           <a:prstGeom prst="rect">
             <a:avLst/>
@@ -4603,8 +4882,8 @@
         </p:nvSpPr>
         <p:spPr>
           <a:xfrm>
-            <a:off x="7452360" y="1691640"/>
-            <a:ext cx="3749040" cy="502920"/>
+            <a:off x="7315200" y="1645920"/>
+            <a:ext cx="4023360" cy="640080"/>
           </a:xfrm>
           <a:prstGeom prst="rect">
             <a:avLst/>
@@ -4622,13 +4901,13 @@
             <a:r>
               <a:rPr lang="en-US" sz="1600" b="1" dirty="0">
                 <a:solidFill>
-                  <a:srgbClr val="232B45"/>
-                </a:solidFill>
-                <a:latin typeface="Calibri" pitchFamily="34" charset="0"/>
-                <a:ea typeface="Calibri" pitchFamily="34" charset="-122"/>
-                <a:cs typeface="Calibri" pitchFamily="34" charset="-120"/>
-              </a:rPr>
-              <a:t>Expense Policy</a:t>
+                  <a:srgbClr val="FFFFFF"/>
+                </a:solidFill>
+                <a:latin typeface="Calibri" pitchFamily="34" charset="0"/>
+                <a:ea typeface="Calibri" pitchFamily="34" charset="-122"/>
+                <a:cs typeface="Calibri" pitchFamily="34" charset="-120"/>
+              </a:rPr>
+              <a:t>Session 3.6 — today</a:t>
             </a:r>
             <a:endParaRPr lang="en-US" sz="1600" dirty="0"/>
           </a:p>
@@ -4642,351 +4921,72 @@
         </p:nvSpPr>
         <p:spPr>
           <a:xfrm>
-            <a:off x="7452360" y="2286000"/>
-            <a:ext cx="3794760" cy="914400"/>
-          </a:xfrm>
-          <a:prstGeom prst="rect">
-            <a:avLst/>
-          </a:prstGeom>
-          <a:noFill/>
-          <a:ln/>
-        </p:spPr>
-        <p:txBody>
-          <a:bodyPr wrap="square" rtlCol="0" anchor="t"/>
+            <a:off x="6629400" y="2468880"/>
+            <a:ext cx="4480560" cy="3108960"/>
+          </a:xfrm>
+          <a:prstGeom prst="rect">
+            <a:avLst/>
+          </a:prstGeom>
+          <a:noFill/>
+          <a:ln/>
+        </p:spPr>
+        <p:txBody>
+          <a:bodyPr wrap="square" rtlCol="0" anchor="ctr"/>
           <a:lstStyle/>
           <a:p>
             <a:pPr indent="0" marL="0">
               <a:lnSpc>
-                <a:spcPct val="130000"/>
+                <a:spcPct val="140000"/>
               </a:lnSpc>
               <a:buNone/>
             </a:pPr>
             <a:r>
-              <a:rPr lang="en-US" sz="1300" i="1" dirty="0">
-                <a:solidFill>
-                  <a:srgbClr val="6B7280"/>
-                </a:solidFill>
-                <a:latin typeface="Calibri" pitchFamily="34" charset="0"/>
-                <a:ea typeface="Calibri" pitchFamily="34" charset="-122"/>
-                <a:cs typeface="Calibri" pitchFamily="34" charset="-120"/>
-              </a:rPr>
-              <a:t>Meals while traveling: $75/day limit</a:t>
-            </a:r>
-            <a:endParaRPr lang="en-US" sz="1300" dirty="0"/>
-          </a:p>
-        </p:txBody>
-      </p:sp>
-      <p:sp>
-        <p:nvSpPr>
-          <p:cNvPr id="13" name="Shape 9"/>
-          <p:cNvSpPr/>
-          <p:nvPr/>
-        </p:nvSpPr>
-        <p:spPr>
-          <a:xfrm>
-            <a:off x="640080" y="3657600"/>
-            <a:ext cx="5212080" cy="1965960"/>
-          </a:xfrm>
-          <a:prstGeom prst="roundRect">
-            <a:avLst>
-              <a:gd name="adj" fmla="val 4651"/>
-            </a:avLst>
-          </a:prstGeom>
-          <a:solidFill>
-            <a:srgbClr val="F4F6FB"/>
-          </a:solidFill>
-          <a:ln/>
-          <a:effectLst>
-            <a:outerShdw sx="100000" sy="100000" kx="0" ky="0" algn="bl" rotWithShape="0" blurRad="101600" dist="38100" dir="2700000">
-              <a:srgbClr val="000000">
-                <a:alpha val="12000"/>
-              </a:srgbClr>
-            </a:outerShdw>
-          </a:effectLst>
-        </p:spPr>
-      </p:sp>
-      <p:sp>
-        <p:nvSpPr>
-          <p:cNvPr id="14" name="Shape 10"/>
-          <p:cNvSpPr/>
-          <p:nvPr/>
-        </p:nvSpPr>
-        <p:spPr>
-          <a:xfrm>
-            <a:off x="914400" y="3931920"/>
-            <a:ext cx="777240" cy="777240"/>
-          </a:xfrm>
-          <a:prstGeom prst="ellipse">
-            <a:avLst/>
-          </a:prstGeom>
-          <a:solidFill>
-            <a:srgbClr val="1E2761"/>
-          </a:solidFill>
-          <a:ln/>
-        </p:spPr>
-      </p:sp>
-      <p:pic>
-        <p:nvPicPr>
-          <p:cNvPr id="15" name="Image 2" descr="icon_umbrella_white.png">    </p:cNvPr>
-          <p:cNvPicPr>
-            <a:picLocks noChangeAspect="1"/>
-          </p:cNvPicPr>
-          <p:nvPr/>
-        </p:nvPicPr>
-        <p:blipFill>
-          <a:blip r:embed="rId3"/>
-          <a:stretch>
-            <a:fillRect/>
-          </a:stretch>
-        </p:blipFill>
-        <p:spPr>
-          <a:xfrm>
-            <a:off x="1108710" y="4126230"/>
-            <a:ext cx="388620" cy="388620"/>
-          </a:xfrm>
-          <a:prstGeom prst="rect">
-            <a:avLst/>
-          </a:prstGeom>
-        </p:spPr>
-      </p:pic>
-      <p:sp>
-        <p:nvSpPr>
-          <p:cNvPr id="16" name="Text 11"/>
-          <p:cNvSpPr/>
-          <p:nvPr/>
-        </p:nvSpPr>
-        <p:spPr>
-          <a:xfrm>
-            <a:off x="1874520" y="3931920"/>
-            <a:ext cx="3749040" cy="502920"/>
-          </a:xfrm>
-          <a:prstGeom prst="rect">
-            <a:avLst/>
-          </a:prstGeom>
-          <a:noFill/>
-          <a:ln/>
-        </p:spPr>
-        <p:txBody>
-          <a:bodyPr wrap="square" rtlCol="0" anchor="ctr"/>
-          <a:lstStyle/>
-          <a:p>
-            <a:pPr indent="0" marL="0">
-              <a:buNone/>
-            </a:pPr>
-            <a:r>
-              <a:rPr lang="en-US" sz="1600" b="1" dirty="0">
-                <a:solidFill>
-                  <a:srgbClr val="232B45"/>
-                </a:solidFill>
-                <a:latin typeface="Calibri" pitchFamily="34" charset="0"/>
-                <a:ea typeface="Calibri" pitchFamily="34" charset="-122"/>
-                <a:cs typeface="Calibri" pitchFamily="34" charset="-120"/>
-              </a:rPr>
-              <a:t>Leave Policy</a:t>
-            </a:r>
-            <a:endParaRPr lang="en-US" sz="1600" dirty="0"/>
-          </a:p>
-        </p:txBody>
-      </p:sp>
-      <p:sp>
-        <p:nvSpPr>
-          <p:cNvPr id="17" name="Text 12"/>
-          <p:cNvSpPr/>
-          <p:nvPr/>
-        </p:nvSpPr>
-        <p:spPr>
-          <a:xfrm>
-            <a:off x="1874520" y="4526280"/>
-            <a:ext cx="3794760" cy="914400"/>
-          </a:xfrm>
-          <a:prstGeom prst="rect">
-            <a:avLst/>
-          </a:prstGeom>
-          <a:noFill/>
-          <a:ln/>
-        </p:spPr>
-        <p:txBody>
-          <a:bodyPr wrap="square" rtlCol="0" anchor="t"/>
-          <a:lstStyle/>
+              <a:rPr lang="en-US" sz="1450" dirty="0">
+                <a:solidFill>
+                  <a:srgbClr val="FFFFFF"/>
+                </a:solidFill>
+                <a:latin typeface="Calibri" pitchFamily="34" charset="0"/>
+                <a:ea typeface="Calibri" pitchFamily="34" charset="-122"/>
+                <a:cs typeface="Calibri" pitchFamily="34" charset="-120"/>
+              </a:rPr>
+              <a:t>Four documents that genuinely cross-reference each other, written by different offices.</a:t>
+            </a:r>
+            <a:endParaRPr lang="en-US" sz="1450" dirty="0"/>
+          </a:p>
           <a:p>
             <a:pPr indent="0" marL="0">
               <a:lnSpc>
-                <a:spcPct val="130000"/>
+                <a:spcPct val="140000"/>
               </a:lnSpc>
               <a:buNone/>
             </a:pPr>
-            <a:r>
-              <a:rPr lang="en-US" sz="1300" i="1" dirty="0">
-                <a:solidFill>
-                  <a:srgbClr val="6B7280"/>
-                </a:solidFill>
-                <a:latin typeface="Calibri" pitchFamily="34" charset="0"/>
-                <a:ea typeface="Calibri" pitchFamily="34" charset="-122"/>
-                <a:cs typeface="Calibri" pitchFamily="34" charset="-120"/>
-              </a:rPr>
-              <a:t>18 PTO days/year, 5 carry over</a:t>
-            </a:r>
-            <a:endParaRPr lang="en-US" sz="1300" dirty="0"/>
-          </a:p>
-        </p:txBody>
-      </p:sp>
-      <p:sp>
-        <p:nvSpPr>
-          <p:cNvPr id="18" name="Shape 13"/>
-          <p:cNvSpPr/>
-          <p:nvPr/>
-        </p:nvSpPr>
-        <p:spPr>
-          <a:xfrm>
-            <a:off x="6217920" y="3657600"/>
-            <a:ext cx="5212080" cy="1965960"/>
-          </a:xfrm>
-          <a:prstGeom prst="roundRect">
-            <a:avLst>
-              <a:gd name="adj" fmla="val 4651"/>
-            </a:avLst>
-          </a:prstGeom>
-          <a:solidFill>
-            <a:srgbClr val="F4F6FB"/>
-          </a:solidFill>
-          <a:ln/>
-          <a:effectLst>
-            <a:outerShdw sx="100000" sy="100000" kx="0" ky="0" algn="bl" rotWithShape="0" blurRad="101600" dist="38100" dir="2700000">
-              <a:srgbClr val="000000">
-                <a:alpha val="12000"/>
-              </a:srgbClr>
-            </a:outerShdw>
-          </a:effectLst>
-        </p:spPr>
-      </p:sp>
-      <p:sp>
-        <p:nvSpPr>
-          <p:cNvPr id="19" name="Shape 14"/>
-          <p:cNvSpPr/>
-          <p:nvPr/>
-        </p:nvSpPr>
-        <p:spPr>
-          <a:xfrm>
-            <a:off x="6492240" y="3931920"/>
-            <a:ext cx="777240" cy="777240"/>
-          </a:xfrm>
-          <a:prstGeom prst="ellipse">
-            <a:avLst/>
-          </a:prstGeom>
-          <a:solidFill>
-            <a:srgbClr val="6B7280"/>
-          </a:solidFill>
-          <a:ln/>
-        </p:spPr>
-      </p:sp>
-      <p:pic>
-        <p:nvPicPr>
-          <p:cNvPr id="20" name="Image 3" descr="icon_shield_white.png">    </p:cNvPr>
-          <p:cNvPicPr>
-            <a:picLocks noChangeAspect="1"/>
-          </p:cNvPicPr>
-          <p:nvPr/>
-        </p:nvPicPr>
-        <p:blipFill>
-          <a:blip r:embed="rId4"/>
-          <a:stretch>
-            <a:fillRect/>
-          </a:stretch>
-        </p:blipFill>
-        <p:spPr>
-          <a:xfrm>
-            <a:off x="6686550" y="4126230"/>
-            <a:ext cx="388620" cy="388620"/>
-          </a:xfrm>
-          <a:prstGeom prst="rect">
-            <a:avLst/>
-          </a:prstGeom>
-        </p:spPr>
-      </p:pic>
-      <p:sp>
-        <p:nvSpPr>
-          <p:cNvPr id="21" name="Text 15"/>
-          <p:cNvSpPr/>
-          <p:nvPr/>
-        </p:nvSpPr>
-        <p:spPr>
-          <a:xfrm>
-            <a:off x="7452360" y="3931920"/>
-            <a:ext cx="3749040" cy="502920"/>
-          </a:xfrm>
-          <a:prstGeom prst="rect">
-            <a:avLst/>
-          </a:prstGeom>
-          <a:noFill/>
-          <a:ln/>
-        </p:spPr>
-        <p:txBody>
-          <a:bodyPr wrap="square" rtlCol="0" anchor="ctr"/>
-          <a:lstStyle/>
-          <a:p>
-            <a:pPr indent="0" marL="0">
-              <a:buNone/>
-            </a:pPr>
-            <a:r>
-              <a:rPr lang="en-US" sz="1600" b="1" dirty="0">
-                <a:solidFill>
-                  <a:srgbClr val="232B45"/>
-                </a:solidFill>
-                <a:latin typeface="Calibri" pitchFamily="34" charset="0"/>
-                <a:ea typeface="Calibri" pitchFamily="34" charset="-122"/>
-                <a:cs typeface="Calibri" pitchFamily="34" charset="-120"/>
-              </a:rPr>
-              <a:t>IT Security Policy</a:t>
-            </a:r>
-            <a:endParaRPr lang="en-US" sz="1600" dirty="0"/>
-          </a:p>
-        </p:txBody>
-      </p:sp>
-      <p:sp>
-        <p:nvSpPr>
-          <p:cNvPr id="22" name="Text 16"/>
-          <p:cNvSpPr/>
-          <p:nvPr/>
-        </p:nvSpPr>
-        <p:spPr>
-          <a:xfrm>
-            <a:off x="7452360" y="4526280"/>
-            <a:ext cx="3794760" cy="914400"/>
-          </a:xfrm>
-          <a:prstGeom prst="rect">
-            <a:avLst/>
-          </a:prstGeom>
-          <a:noFill/>
-          <a:ln/>
-        </p:spPr>
-        <p:txBody>
-          <a:bodyPr wrap="square" rtlCol="0" anchor="t"/>
-          <a:lstStyle/>
+            <a:endParaRPr lang="en-US" sz="1450" dirty="0"/>
+          </a:p>
           <a:p>
             <a:pPr indent="0" marL="0">
               <a:lnSpc>
-                <a:spcPct val="130000"/>
+                <a:spcPct val="140000"/>
               </a:lnSpc>
               <a:buNone/>
             </a:pPr>
             <a:r>
-              <a:rPr lang="en-US" sz="1300" i="1" dirty="0">
-                <a:solidFill>
-                  <a:srgbClr val="6B7280"/>
-                </a:solidFill>
-                <a:latin typeface="Calibri" pitchFamily="34" charset="0"/>
-                <a:ea typeface="Calibri" pitchFamily="34" charset="-122"/>
-                <a:cs typeface="Calibri" pitchFamily="34" charset="-120"/>
-              </a:rPr>
-              <a:t>Passwords rotate every 180 days</a:t>
-            </a:r>
-            <a:endParaRPr lang="en-US" sz="1300" dirty="0"/>
-          </a:p>
-        </p:txBody>
-      </p:sp>
-      <p:sp>
-        <p:nvSpPr>
-          <p:cNvPr id="23" name="Text 17"/>
+              <a:rPr lang="en-US" sz="1450" dirty="0">
+                <a:solidFill>
+                  <a:srgbClr val="FFFFFF"/>
+                </a:solidFill>
+                <a:latin typeface="Calibri" pitchFamily="34" charset="0"/>
+                <a:ea typeface="Calibri" pitchFamily="34" charset="-122"/>
+                <a:cs typeface="Calibri" pitchFamily="34" charset="-120"/>
+              </a:rPr>
+              <a:t>A chunk from the WRONG document can score deceptively well just by mentioning the right topic in passing.</a:t>
+            </a:r>
+            <a:endParaRPr lang="en-US" sz="1450" dirty="0"/>
+          </a:p>
+        </p:txBody>
+      </p:sp>
+      <p:sp>
+        <p:nvSpPr>
+          <p:cNvPr id="13" name="Text 9"/>
           <p:cNvSpPr/>
           <p:nvPr/>
         </p:nvSpPr>
@@ -5011,7 +5011,7 @@
             <a:r>
               <a:rPr lang="en-US" sz="1000" dirty="0">
                 <a:solidFill>
-                  <a:srgbClr val="6B7280"/>
+                  <a:srgbClr val="7A6B78"/>
                 </a:solidFill>
                 <a:latin typeface="Calibri" pitchFamily="34" charset="0"/>
                 <a:ea typeface="Calibri" pitchFamily="34" charset="-122"/>
@@ -5025,7 +5025,7 @@
       </p:sp>
       <p:sp>
         <p:nvSpPr>
-          <p:cNvPr id="24" name="Text 18"/>
+          <p:cNvPr id="14" name="Text 10"/>
           <p:cNvSpPr/>
           <p:nvPr/>
         </p:nvSpPr>
@@ -5050,7 +5050,7 @@
             <a:r>
               <a:rPr lang="en-US" sz="1000" dirty="0">
                 <a:solidFill>
-                  <a:srgbClr val="6B7280"/>
+                  <a:srgbClr val="7A6B78"/>
                 </a:solidFill>
                 <a:latin typeface="Calibri" pitchFamily="34" charset="0"/>
                 <a:ea typeface="Calibri" pitchFamily="34" charset="-122"/>
@@ -5121,7 +5121,7 @@
             <a:r>
               <a:rPr lang="en-US" sz="2800" b="1" dirty="0">
                 <a:solidFill>
-                  <a:srgbClr val="232B45"/>
+                  <a:srgbClr val="2B1A2E"/>
                 </a:solidFill>
                 <a:latin typeface="Cambria" pitchFamily="34" charset="0"/>
                 <a:ea typeface="Cambria" pitchFamily="34" charset="-122"/>
@@ -5150,7 +5150,7 @@
             </a:avLst>
           </a:prstGeom>
           <a:solidFill>
-            <a:srgbClr val="F4F6FB"/>
+            <a:srgbClr val="F7F1F4"/>
           </a:solidFill>
           <a:ln/>
           <a:effectLst>
@@ -5177,14 +5177,14 @@
             <a:avLst/>
           </a:prstGeom>
           <a:solidFill>
-            <a:srgbClr val="1E2761"/>
+            <a:srgbClr val="4A2545"/>
           </a:solidFill>
           <a:ln/>
         </p:spPr>
       </p:sp>
       <p:pic>
         <p:nvPicPr>
-          <p:cNvPr id="5" name="Image 0" descr="icon_file_white.png">    </p:cNvPr>
+          <p:cNvPr id="5" name="Image 0" descr="icon_grad_white.png">    </p:cNvPr>
           <p:cNvPicPr>
             <a:picLocks noChangeAspect="1"/>
           </p:cNvPicPr>
@@ -5233,7 +5233,7 @@
             <a:r>
               <a:rPr lang="en-US" sz="1500" b="1" dirty="0">
                 <a:solidFill>
-                  <a:srgbClr val="232B45"/>
+                  <a:srgbClr val="2B1A2E"/>
                 </a:solidFill>
                 <a:latin typeface="Calibri" pitchFamily="34" charset="0"/>
                 <a:ea typeface="Calibri" pitchFamily="34" charset="-122"/>
@@ -5275,7 +5275,7 @@
             <a:r>
               <a:rPr lang="en-US" sz="1150" dirty="0">
                 <a:solidFill>
-                  <a:srgbClr val="6B7280"/>
+                  <a:srgbClr val="7A6B78"/>
                 </a:solidFill>
                 <a:latin typeface="Calibri" pitchFamily="34" charset="0"/>
                 <a:ea typeface="Calibri" pitchFamily="34" charset="-122"/>
@@ -5302,7 +5302,7 @@
             <a:avLst/>
           </a:prstGeom>
           <a:solidFill>
-            <a:srgbClr val="FF6B6B"/>
+            <a:srgbClr val="C45B6E"/>
           </a:solidFill>
           <a:ln/>
         </p:spPr>
@@ -5348,7 +5348,7 @@
             </a:avLst>
           </a:prstGeom>
           <a:solidFill>
-            <a:srgbClr val="F4F6FB"/>
+            <a:srgbClr val="F7F1F4"/>
           </a:solidFill>
           <a:ln/>
           <a:effectLst>
@@ -5375,7 +5375,7 @@
             <a:avLst/>
           </a:prstGeom>
           <a:solidFill>
-            <a:srgbClr val="FF6B6B"/>
+            <a:srgbClr val="C45B6E"/>
           </a:solidFill>
           <a:ln/>
         </p:spPr>
@@ -5431,7 +5431,7 @@
             <a:r>
               <a:rPr lang="en-US" sz="1500" b="1" dirty="0">
                 <a:solidFill>
-                  <a:srgbClr val="232B45"/>
+                  <a:srgbClr val="2B1A2E"/>
                 </a:solidFill>
                 <a:latin typeface="Calibri" pitchFamily="34" charset="0"/>
                 <a:ea typeface="Calibri" pitchFamily="34" charset="-122"/>
@@ -5473,7 +5473,7 @@
             <a:r>
               <a:rPr lang="en-US" sz="1150" dirty="0">
                 <a:solidFill>
-                  <a:srgbClr val="6B7280"/>
+                  <a:srgbClr val="7A6B78"/>
                 </a:solidFill>
                 <a:latin typeface="Calibri" pitchFamily="34" charset="0"/>
                 <a:ea typeface="Calibri" pitchFamily="34" charset="-122"/>
@@ -5500,7 +5500,7 @@
             <a:avLst/>
           </a:prstGeom>
           <a:solidFill>
-            <a:srgbClr val="FF6B6B"/>
+            <a:srgbClr val="C45B6E"/>
           </a:solidFill>
           <a:ln/>
         </p:spPr>
@@ -5546,7 +5546,7 @@
             </a:avLst>
           </a:prstGeom>
           <a:solidFill>
-            <a:srgbClr val="F4F6FB"/>
+            <a:srgbClr val="F7F1F4"/>
           </a:solidFill>
           <a:ln/>
           <a:effectLst>
@@ -5573,7 +5573,7 @@
             <a:avLst/>
           </a:prstGeom>
           <a:solidFill>
-            <a:srgbClr val="F4B942"/>
+            <a:srgbClr val="E8B339"/>
           </a:solidFill>
           <a:ln/>
         </p:spPr>
@@ -5629,7 +5629,7 @@
             <a:r>
               <a:rPr lang="en-US" sz="1500" b="1" dirty="0">
                 <a:solidFill>
-                  <a:srgbClr val="232B45"/>
+                  <a:srgbClr val="2B1A2E"/>
                 </a:solidFill>
                 <a:latin typeface="Calibri" pitchFamily="34" charset="0"/>
                 <a:ea typeface="Calibri" pitchFamily="34" charset="-122"/>
@@ -5671,7 +5671,7 @@
             <a:r>
               <a:rPr lang="en-US" sz="1150" dirty="0">
                 <a:solidFill>
-                  <a:srgbClr val="6B7280"/>
+                  <a:srgbClr val="7A6B78"/>
                 </a:solidFill>
                 <a:latin typeface="Calibri" pitchFamily="34" charset="0"/>
                 <a:ea typeface="Calibri" pitchFamily="34" charset="-122"/>
@@ -5698,7 +5698,7 @@
             <a:avLst/>
           </a:prstGeom>
           <a:solidFill>
-            <a:srgbClr val="FF6B6B"/>
+            <a:srgbClr val="C45B6E"/>
           </a:solidFill>
           <a:ln/>
         </p:spPr>
@@ -5744,7 +5744,7 @@
             </a:avLst>
           </a:prstGeom>
           <a:solidFill>
-            <a:srgbClr val="F4F6FB"/>
+            <a:srgbClr val="F7F1F4"/>
           </a:solidFill>
           <a:ln/>
           <a:effectLst>
@@ -5771,14 +5771,14 @@
             <a:avLst/>
           </a:prstGeom>
           <a:solidFill>
-            <a:srgbClr val="6B7280"/>
+            <a:srgbClr val="7A6B78"/>
           </a:solidFill>
           <a:ln/>
         </p:spPr>
       </p:sp>
       <p:pic>
         <p:nvPicPr>
-          <p:cNvPr id="26" name="Image 6" descr="icon_usertie_white.png">    </p:cNvPr>
+          <p:cNvPr id="26" name="Image 6" descr="icon_usergrad_white.png">    </p:cNvPr>
           <p:cNvPicPr>
             <a:picLocks noChangeAspect="1"/>
           </p:cNvPicPr>
@@ -5827,7 +5827,7 @@
             <a:r>
               <a:rPr lang="en-US" sz="1500" b="1" dirty="0">
                 <a:solidFill>
-                  <a:srgbClr val="232B45"/>
+                  <a:srgbClr val="2B1A2E"/>
                 </a:solidFill>
                 <a:latin typeface="Calibri" pitchFamily="34" charset="0"/>
                 <a:ea typeface="Calibri" pitchFamily="34" charset="-122"/>
@@ -5869,7 +5869,7 @@
             <a:r>
               <a:rPr lang="en-US" sz="1150" dirty="0">
                 <a:solidFill>
-                  <a:srgbClr val="6B7280"/>
+                  <a:srgbClr val="7A6B78"/>
                 </a:solidFill>
                 <a:latin typeface="Calibri" pitchFamily="34" charset="0"/>
                 <a:ea typeface="Calibri" pitchFamily="34" charset="-122"/>
@@ -5908,13 +5908,13 @@
             <a:r>
               <a:rPr lang="en-US" sz="1400" i="1" dirty="0">
                 <a:solidFill>
-                  <a:srgbClr val="6B7280"/>
-                </a:solidFill>
-                <a:latin typeface="Calibri" pitchFamily="34" charset="0"/>
-                <a:ea typeface="Calibri" pitchFamily="34" charset="-122"/>
-                <a:cs typeface="Calibri" pitchFamily="34" charset="-120"/>
-              </a:rPr>
-              <a:t>Every box above is a function you wrote earlier this week — today just wires them together over a bigger, messier corpus.</a:t>
+                  <a:srgbClr val="7A6B78"/>
+                </a:solidFill>
+                <a:latin typeface="Calibri" pitchFamily="34" charset="0"/>
+                <a:ea typeface="Calibri" pitchFamily="34" charset="-122"/>
+                <a:cs typeface="Calibri" pitchFamily="34" charset="-120"/>
+              </a:rPr>
+              <a:t>Every box above is a function you wrote earlier this week — today just wires them together over four overlapping documents.</a:t>
             </a:r>
             <a:endParaRPr lang="en-US" sz="1400" dirty="0"/>
           </a:p>
@@ -5947,7 +5947,7 @@
             <a:r>
               <a:rPr lang="en-US" sz="1000" dirty="0">
                 <a:solidFill>
-                  <a:srgbClr val="6B7280"/>
+                  <a:srgbClr val="7A6B78"/>
                 </a:solidFill>
                 <a:latin typeface="Calibri" pitchFamily="34" charset="0"/>
                 <a:ea typeface="Calibri" pitchFamily="34" charset="-122"/>
@@ -5986,7 +5986,7 @@
             <a:r>
               <a:rPr lang="en-US" sz="1000" dirty="0">
                 <a:solidFill>
-                  <a:srgbClr val="6B7280"/>
+                  <a:srgbClr val="7A6B78"/>
                 </a:solidFill>
                 <a:latin typeface="Calibri" pitchFamily="34" charset="0"/>
                 <a:ea typeface="Calibri" pitchFamily="34" charset="-122"/>
@@ -6012,7 +6012,7 @@
     <p:bg>
       <p:bgPr>
         <a:solidFill>
-          <a:srgbClr val="1E2761"/>
+          <a:srgbClr val="4A2545"/>
         </a:solidFill>
       </p:bgPr>
     </p:bg>
@@ -6038,14 +6038,14 @@
         </p:nvSpPr>
         <p:spPr>
           <a:xfrm>
-            <a:off x="822960" y="640080"/>
+            <a:off x="822960" y="548640"/>
             <a:ext cx="777240" cy="777240"/>
           </a:xfrm>
           <a:prstGeom prst="ellipse">
             <a:avLst/>
           </a:prstGeom>
           <a:solidFill>
-            <a:srgbClr val="FF6B6B"/>
+            <a:srgbClr val="C45B6E"/>
           </a:solidFill>
           <a:ln/>
         </p:spPr>
@@ -6066,7 +6066,7 @@
         </p:blipFill>
         <p:spPr>
           <a:xfrm>
-            <a:off x="997839" y="814959"/>
+            <a:off x="997839" y="723519"/>
             <a:ext cx="427482" cy="427482"/>
           </a:xfrm>
           <a:prstGeom prst="rect">
@@ -6082,7 +6082,7 @@
         </p:nvSpPr>
         <p:spPr>
           <a:xfrm>
-            <a:off x="1828800" y="640080"/>
+            <a:off x="1828800" y="548640"/>
             <a:ext cx="9418320" cy="777240"/>
           </a:xfrm>
           <a:prstGeom prst="rect">
@@ -6099,7 +6099,7 @@
               <a:buNone/>
             </a:pPr>
             <a:r>
-              <a:rPr lang="en-US" sz="2500" b="1" dirty="0">
+              <a:rPr lang="en-US" sz="2400" b="1" dirty="0">
                 <a:solidFill>
                   <a:srgbClr val="FFFFFF"/>
                 </a:solidFill>
@@ -6107,9 +6107,9 @@
                 <a:ea typeface="Cambria" pitchFamily="34" charset="-122"/>
                 <a:cs typeface="Cambria" pitchFamily="34" charset="-120"/>
               </a:rPr>
-              <a:t>A real bug, found by actually running the code</a:t>
-            </a:r>
-            <a:endParaRPr lang="en-US" sz="2500" dirty="0"/>
+              <a:t>Two real bugs, found by actually running the code</a:t>
+            </a:r>
+            <a:endParaRPr lang="en-US" sz="2400" dirty="0"/>
           </a:p>
         </p:txBody>
       </p:sp>
@@ -6121,107 +6121,7 @@
         </p:nvSpPr>
         <p:spPr>
           <a:xfrm>
-            <a:off x="822960" y="1691640"/>
-            <a:ext cx="10515600" cy="914400"/>
-          </a:xfrm>
-          <a:prstGeom prst="roundRect">
-            <a:avLst>
-              <a:gd name="adj" fmla="val 8000"/>
-            </a:avLst>
-          </a:prstGeom>
-          <a:solidFill>
-            <a:srgbClr val="FFFFFF"/>
-          </a:solidFill>
-          <a:ln/>
-        </p:spPr>
-      </p:sp>
-      <p:sp>
-        <p:nvSpPr>
-          <p:cNvPr id="6" name="Text 3"/>
-          <p:cNvSpPr/>
-          <p:nvPr/>
-        </p:nvSpPr>
-        <p:spPr>
-          <a:xfrm>
-            <a:off x="1097280" y="1691640"/>
-            <a:ext cx="9966960" cy="914400"/>
-          </a:xfrm>
-          <a:prstGeom prst="rect">
-            <a:avLst/>
-          </a:prstGeom>
-          <a:noFill/>
-          <a:ln/>
-        </p:spPr>
-        <p:txBody>
-          <a:bodyPr wrap="square" rtlCol="0" anchor="ctr"/>
-          <a:lstStyle/>
-          <a:p>
-            <a:pPr indent="0" marL="0">
-              <a:buNone/>
-            </a:pPr>
-            <a:r>
-              <a:rPr lang="en-US" sz="1800" i="1" dirty="0">
-                <a:solidFill>
-                  <a:srgbClr val="232B45"/>
-                </a:solidFill>
-                <a:latin typeface="Calibri" pitchFamily="34" charset="0"/>
-                <a:ea typeface="Calibri" pitchFamily="34" charset="-122"/>
-                <a:cs typeface="Calibri" pitchFamily="34" charset="-120"/>
-              </a:rPr>
-              <a:t>“What is the home office equipment stipend amount?”</a:t>
-            </a:r>
-            <a:endParaRPr lang="en-US" sz="1800" dirty="0"/>
-          </a:p>
-        </p:txBody>
-      </p:sp>
-      <p:sp>
-        <p:nvSpPr>
-          <p:cNvPr id="7" name="Text 4"/>
-          <p:cNvSpPr/>
-          <p:nvPr/>
-        </p:nvSpPr>
-        <p:spPr>
-          <a:xfrm>
-            <a:off x="822960" y="2880360"/>
-            <a:ext cx="10515600" cy="365760"/>
-          </a:xfrm>
-          <a:prstGeom prst="rect">
-            <a:avLst/>
-          </a:prstGeom>
-          <a:noFill/>
-          <a:ln/>
-        </p:spPr>
-        <p:txBody>
-          <a:bodyPr wrap="square" rtlCol="0" anchor="ctr"/>
-          <a:lstStyle/>
-          <a:p>
-            <a:pPr indent="0" marL="0">
-              <a:buNone/>
-            </a:pPr>
-            <a:r>
-              <a:rPr lang="en-US" sz="1300" b="1" dirty="0">
-                <a:solidFill>
-                  <a:srgbClr val="CADCFC"/>
-                </a:solidFill>
-                <a:latin typeface="Calibri" pitchFamily="34" charset="0"/>
-                <a:ea typeface="Calibri" pitchFamily="34" charset="-122"/>
-                <a:cs typeface="Calibri" pitchFamily="34" charset="-120"/>
-              </a:rPr>
-              <a:t>Correct source</a:t>
-            </a:r>
-            <a:endParaRPr lang="en-US" sz="1300" dirty="0"/>
-          </a:p>
-        </p:txBody>
-      </p:sp>
-      <p:sp>
-        <p:nvSpPr>
-          <p:cNvPr id="8" name="Shape 5"/>
-          <p:cNvSpPr/>
-          <p:nvPr/>
-        </p:nvSpPr>
-        <p:spPr>
-          <a:xfrm>
-            <a:off x="822960" y="3246120"/>
+            <a:off x="822960" y="1508760"/>
             <a:ext cx="10515600" cy="777240"/>
           </a:xfrm>
           <a:prstGeom prst="roundRect">
@@ -6230,100 +6130,137 @@
             </a:avLst>
           </a:prstGeom>
           <a:solidFill>
-            <a:srgbClr val="FFFFFF">
-              <a:alpha val="12000"/>
-            </a:srgbClr>
+            <a:srgbClr val="FFFFFF"/>
           </a:solidFill>
           <a:ln/>
         </p:spPr>
       </p:sp>
       <p:sp>
         <p:nvSpPr>
-          <p:cNvPr id="9" name="Text 6"/>
-          <p:cNvSpPr/>
-          <p:nvPr/>
-        </p:nvSpPr>
-        <p:spPr>
-          <a:xfrm>
-            <a:off x="1051560" y="3246120"/>
-            <a:ext cx="10058400" cy="777240"/>
-          </a:xfrm>
-          <a:prstGeom prst="rect">
-            <a:avLst/>
-          </a:prstGeom>
-          <a:noFill/>
-          <a:ln/>
-        </p:spPr>
-        <p:txBody>
-          <a:bodyPr wrap="square" rtlCol="0" anchor="ctr"/>
-          <a:lstStyle/>
-          <a:p>
-            <a:pPr indent="0" marL="0">
-              <a:buNone/>
-            </a:pPr>
-            <a:r>
-              <a:rPr lang="en-US" sz="1500" b="1" dirty="0">
-                <a:solidFill>
-                  <a:srgbClr val="F4B942"/>
-                </a:solidFill>
-                <a:latin typeface="Calibri" pitchFamily="34" charset="0"/>
-                <a:ea typeface="Calibri" pitchFamily="34" charset="-122"/>
-                <a:cs typeface="Calibri" pitchFamily="34" charset="-120"/>
-              </a:rPr>
-              <a:t>Remote Work Policy — Section 4, “Home Office Equipment Stipend”</a:t>
-            </a:r>
-            <a:endParaRPr lang="en-US" sz="1500" dirty="0"/>
-          </a:p>
-        </p:txBody>
-      </p:sp>
-      <p:sp>
-        <p:nvSpPr>
-          <p:cNvPr id="10" name="Text 7"/>
-          <p:cNvSpPr/>
-          <p:nvPr/>
-        </p:nvSpPr>
-        <p:spPr>
-          <a:xfrm>
-            <a:off x="822960" y="4160520"/>
-            <a:ext cx="10515600" cy="365760"/>
-          </a:xfrm>
-          <a:prstGeom prst="rect">
-            <a:avLst/>
-          </a:prstGeom>
-          <a:noFill/>
-          <a:ln/>
-        </p:spPr>
-        <p:txBody>
-          <a:bodyPr wrap="square" rtlCol="0" anchor="ctr"/>
-          <a:lstStyle/>
-          <a:p>
-            <a:pPr indent="0" marL="0">
-              <a:buNone/>
-            </a:pPr>
-            <a:r>
-              <a:rPr lang="en-US" sz="1300" b="1" dirty="0">
-                <a:solidFill>
-                  <a:srgbClr val="CADCFC"/>
-                </a:solidFill>
-                <a:latin typeface="Calibri" pitchFamily="34" charset="0"/>
-                <a:ea typeface="Calibri" pitchFamily="34" charset="-122"/>
-                <a:cs typeface="Calibri" pitchFamily="34" charset="-120"/>
-              </a:rPr>
-              <a:t>What retrieval actually returns</a:t>
-            </a:r>
-            <a:endParaRPr lang="en-US" sz="1300" dirty="0"/>
-          </a:p>
-        </p:txBody>
-      </p:sp>
-      <p:sp>
-        <p:nvSpPr>
-          <p:cNvPr id="11" name="Shape 8"/>
-          <p:cNvSpPr/>
-          <p:nvPr/>
-        </p:nvSpPr>
-        <p:spPr>
-          <a:xfrm>
-            <a:off x="822960" y="4526280"/>
+          <p:cNvPr id="6" name="Text 3"/>
+          <p:cNvSpPr/>
+          <p:nvPr/>
+        </p:nvSpPr>
+        <p:spPr>
+          <a:xfrm>
+            <a:off x="1097280" y="1508760"/>
+            <a:ext cx="9966960" cy="777240"/>
+          </a:xfrm>
+          <a:prstGeom prst="rect">
+            <a:avLst/>
+          </a:prstGeom>
+          <a:noFill/>
+          <a:ln/>
+        </p:spPr>
+        <p:txBody>
+          <a:bodyPr wrap="square" rtlCol="0" anchor="ctr"/>
+          <a:lstStyle/>
+          <a:p>
+            <a:pPr indent="0" marL="0">
+              <a:buNone/>
+            </a:pPr>
+            <a:r>
+              <a:rPr lang="en-US" sz="1550" i="1" dirty="0">
+                <a:solidFill>
+                  <a:srgbClr val="2B1A2E"/>
+                </a:solidFill>
+                <a:latin typeface="Calibri" pitchFamily="34" charset="0"/>
+                <a:ea typeface="Calibri" pitchFamily="34" charset="-122"/>
+                <a:cs typeface="Calibri" pitchFamily="34" charset="-120"/>
+              </a:rPr>
+              <a:t>“What is the maximum course load for a student on probation?”</a:t>
+            </a:r>
+            <a:endParaRPr lang="en-US" sz="1550" dirty="0"/>
+          </a:p>
+        </p:txBody>
+      </p:sp>
+      <p:sp>
+        <p:nvSpPr>
+          <p:cNvPr id="7" name="Text 4"/>
+          <p:cNvSpPr/>
+          <p:nvPr/>
+        </p:nvSpPr>
+        <p:spPr>
+          <a:xfrm>
+            <a:off x="822960" y="2377440"/>
+            <a:ext cx="5120640" cy="457200"/>
+          </a:xfrm>
+          <a:prstGeom prst="rect">
+            <a:avLst/>
+          </a:prstGeom>
+          <a:noFill/>
+          <a:ln/>
+        </p:spPr>
+        <p:txBody>
+          <a:bodyPr wrap="square" rtlCol="0" anchor="ctr"/>
+          <a:lstStyle/>
+          <a:p>
+            <a:pPr indent="0" marL="0">
+              <a:buNone/>
+            </a:pPr>
+            <a:r>
+              <a:rPr lang="en-US" sz="1350" b="1" dirty="0">
+                <a:solidFill>
+                  <a:srgbClr val="E8B339"/>
+                </a:solidFill>
+                <a:latin typeface="Calibri" pitchFamily="34" charset="0"/>
+                <a:ea typeface="Calibri" pitchFamily="34" charset="-122"/>
+                <a:cs typeface="Calibri" pitchFamily="34" charset="-120"/>
+              </a:rPr>
+              <a:t>Correct source: Academic Standing Policy</a:t>
+            </a:r>
+            <a:endParaRPr lang="en-US" sz="1350" dirty="0"/>
+          </a:p>
+        </p:txBody>
+      </p:sp>
+      <p:sp>
+        <p:nvSpPr>
+          <p:cNvPr id="8" name="Text 5"/>
+          <p:cNvSpPr/>
+          <p:nvPr/>
+        </p:nvSpPr>
+        <p:spPr>
+          <a:xfrm>
+            <a:off x="6035040" y="2377440"/>
+            <a:ext cx="5303520" cy="457200"/>
+          </a:xfrm>
+          <a:prstGeom prst="rect">
+            <a:avLst/>
+          </a:prstGeom>
+          <a:noFill/>
+          <a:ln/>
+        </p:spPr>
+        <p:txBody>
+          <a:bodyPr wrap="square" rtlCol="0" anchor="ctr"/>
+          <a:lstStyle/>
+          <a:p>
+            <a:pPr indent="0" marL="0">
+              <a:buNone/>
+            </a:pPr>
+            <a:r>
+              <a:rPr lang="en-US" sz="1350" b="1" dirty="0">
+                <a:solidFill>
+                  <a:srgbClr val="C45B6E"/>
+                </a:solidFill>
+                <a:latin typeface="Calibri" pitchFamily="34" charset="0"/>
+                <a:ea typeface="Calibri" pitchFamily="34" charset="-122"/>
+                <a:cs typeface="Calibri" pitchFamily="34" charset="-120"/>
+              </a:rPr>
+              <a:t>Actually retrieved: Registration Guide</a:t>
+            </a:r>
+            <a:endParaRPr lang="en-US" sz="1350" dirty="0"/>
+          </a:p>
+        </p:txBody>
+      </p:sp>
+      <p:sp>
+        <p:nvSpPr>
+          <p:cNvPr id="9" name="Shape 6"/>
+          <p:cNvSpPr/>
+          <p:nvPr/>
+        </p:nvSpPr>
+        <p:spPr>
+          <a:xfrm>
+            <a:off x="822960" y="3840480"/>
             <a:ext cx="10515600" cy="777240"/>
           </a:xfrm>
           <a:prstGeom prst="roundRect">
@@ -6332,49 +6269,125 @@
             </a:avLst>
           </a:prstGeom>
           <a:solidFill>
-            <a:srgbClr val="FFFFFF">
-              <a:alpha val="12000"/>
-            </a:srgbClr>
+            <a:srgbClr val="FFFFFF"/>
           </a:solidFill>
           <a:ln/>
         </p:spPr>
       </p:sp>
       <p:sp>
         <p:nvSpPr>
+          <p:cNvPr id="10" name="Text 7"/>
+          <p:cNvSpPr/>
+          <p:nvPr/>
+        </p:nvSpPr>
+        <p:spPr>
+          <a:xfrm>
+            <a:off x="1097280" y="3840480"/>
+            <a:ext cx="9966960" cy="777240"/>
+          </a:xfrm>
+          <a:prstGeom prst="rect">
+            <a:avLst/>
+          </a:prstGeom>
+          <a:noFill/>
+          <a:ln/>
+        </p:spPr>
+        <p:txBody>
+          <a:bodyPr wrap="square" rtlCol="0" anchor="ctr"/>
+          <a:lstStyle/>
+          <a:p>
+            <a:pPr indent="0" marL="0">
+              <a:buNone/>
+            </a:pPr>
+            <a:r>
+              <a:rPr lang="en-US" sz="1550" i="1" dirty="0">
+                <a:solidFill>
+                  <a:srgbClr val="2B1A2E"/>
+                </a:solidFill>
+                <a:latin typeface="Calibri" pitchFamily="34" charset="0"/>
+                <a:ea typeface="Calibri" pitchFamily="34" charset="-122"/>
+                <a:cs typeface="Calibri" pitchFamily="34" charset="-120"/>
+              </a:rPr>
+              <a:t>“What happens if I drop below full-time enrollment in a dorm?”</a:t>
+            </a:r>
+            <a:endParaRPr lang="en-US" sz="1550" dirty="0"/>
+          </a:p>
+        </p:txBody>
+      </p:sp>
+      <p:sp>
+        <p:nvSpPr>
+          <p:cNvPr id="11" name="Text 8"/>
+          <p:cNvSpPr/>
+          <p:nvPr/>
+        </p:nvSpPr>
+        <p:spPr>
+          <a:xfrm>
+            <a:off x="822960" y="4709160"/>
+            <a:ext cx="5120640" cy="457200"/>
+          </a:xfrm>
+          <a:prstGeom prst="rect">
+            <a:avLst/>
+          </a:prstGeom>
+          <a:noFill/>
+          <a:ln/>
+        </p:spPr>
+        <p:txBody>
+          <a:bodyPr wrap="square" rtlCol="0" anchor="ctr"/>
+          <a:lstStyle/>
+          <a:p>
+            <a:pPr indent="0" marL="0">
+              <a:buNone/>
+            </a:pPr>
+            <a:r>
+              <a:rPr lang="en-US" sz="1350" b="1" dirty="0">
+                <a:solidFill>
+                  <a:srgbClr val="E8B339"/>
+                </a:solidFill>
+                <a:latin typeface="Calibri" pitchFamily="34" charset="0"/>
+                <a:ea typeface="Calibri" pitchFamily="34" charset="-122"/>
+                <a:cs typeface="Calibri" pitchFamily="34" charset="-120"/>
+              </a:rPr>
+              <a:t>Correct source: Housing Handbook</a:t>
+            </a:r>
+            <a:endParaRPr lang="en-US" sz="1350" dirty="0"/>
+          </a:p>
+        </p:txBody>
+      </p:sp>
+      <p:sp>
+        <p:nvSpPr>
           <p:cNvPr id="12" name="Text 9"/>
           <p:cNvSpPr/>
           <p:nvPr/>
         </p:nvSpPr>
         <p:spPr>
           <a:xfrm>
-            <a:off x="1051560" y="4526280"/>
-            <a:ext cx="10058400" cy="777240"/>
-          </a:xfrm>
-          <a:prstGeom prst="rect">
-            <a:avLst/>
-          </a:prstGeom>
-          <a:noFill/>
-          <a:ln/>
-        </p:spPr>
-        <p:txBody>
-          <a:bodyPr wrap="square" rtlCol="0" anchor="ctr"/>
-          <a:lstStyle/>
-          <a:p>
-            <a:pPr indent="0" marL="0">
-              <a:buNone/>
-            </a:pPr>
-            <a:r>
-              <a:rPr lang="en-US" sz="1500" b="1" dirty="0">
-                <a:solidFill>
-                  <a:srgbClr val="FF6B6B"/>
-                </a:solidFill>
-                <a:latin typeface="Calibri" pitchFamily="34" charset="0"/>
-                <a:ea typeface="Calibri" pitchFamily="34" charset="-122"/>
-                <a:cs typeface="Calibri" pitchFamily="34" charset="-120"/>
-              </a:rPr>
-              <a:t>Expense Policy — a one-line cross-reference to “stipend”</a:t>
-            </a:r>
-            <a:endParaRPr lang="en-US" sz="1500" dirty="0"/>
+            <a:off x="6035040" y="4709160"/>
+            <a:ext cx="5303520" cy="457200"/>
+          </a:xfrm>
+          <a:prstGeom prst="rect">
+            <a:avLst/>
+          </a:prstGeom>
+          <a:noFill/>
+          <a:ln/>
+        </p:spPr>
+        <p:txBody>
+          <a:bodyPr wrap="square" rtlCol="0" anchor="ctr"/>
+          <a:lstStyle/>
+          <a:p>
+            <a:pPr indent="0" marL="0">
+              <a:buNone/>
+            </a:pPr>
+            <a:r>
+              <a:rPr lang="en-US" sz="1350" b="1" dirty="0">
+                <a:solidFill>
+                  <a:srgbClr val="C45B6E"/>
+                </a:solidFill>
+                <a:latin typeface="Calibri" pitchFamily="34" charset="0"/>
+                <a:ea typeface="Calibri" pitchFamily="34" charset="-122"/>
+                <a:cs typeface="Calibri" pitchFamily="34" charset="-120"/>
+              </a:rPr>
+              <a:t>Actually retrieved: Registration Guide</a:t>
+            </a:r>
+            <a:endParaRPr lang="en-US" sz="1350" dirty="0"/>
           </a:p>
         </p:txBody>
       </p:sp>
@@ -6405,7 +6418,7 @@
             <a:r>
               <a:rPr lang="en-US" sz="1000" dirty="0">
                 <a:solidFill>
-                  <a:srgbClr val="6B7280"/>
+                  <a:srgbClr val="7A6B78"/>
                 </a:solidFill>
                 <a:latin typeface="Calibri" pitchFamily="34" charset="0"/>
                 <a:ea typeface="Calibri" pitchFamily="34" charset="-122"/>
@@ -6444,7 +6457,7 @@
             <a:r>
               <a:rPr lang="en-US" sz="1000" dirty="0">
                 <a:solidFill>
-                  <a:srgbClr val="6B7280"/>
+                  <a:srgbClr val="7A6B78"/>
                 </a:solidFill>
                 <a:latin typeface="Calibri" pitchFamily="34" charset="0"/>
                 <a:ea typeface="Calibri" pitchFamily="34" charset="-122"/>
@@ -6515,13 +6528,13 @@
             <a:r>
               <a:rPr lang="en-US" sz="2800" b="1" dirty="0">
                 <a:solidFill>
-                  <a:srgbClr val="232B45"/>
+                  <a:srgbClr val="2B1A2E"/>
                 </a:solidFill>
                 <a:latin typeface="Cambria" pitchFamily="34" charset="0"/>
                 <a:ea typeface="Cambria" pitchFamily="34" charset="-122"/>
                 <a:cs typeface="Cambria" pitchFamily="34" charset="-120"/>
               </a:rPr>
-              <a:t>Diagnosis: the bug isn't where you'd expect</a:t>
+              <a:t>Diagnosis: one merged chunk, two wrong answers</a:t>
             </a:r>
             <a:endParaRPr lang="en-US" sz="2800" dirty="0"/>
           </a:p>
@@ -6542,7 +6555,7 @@
             <a:avLst/>
           </a:prstGeom>
           <a:solidFill>
-            <a:srgbClr val="FF6B6B"/>
+            <a:srgbClr val="C45B6E"/>
           </a:solidFill>
           <a:ln/>
         </p:spPr>
@@ -6613,13 +6626,13 @@
             <a:r>
               <a:rPr lang="en-US" sz="1600" b="1" dirty="0">
                 <a:solidFill>
-                  <a:srgbClr val="232B45"/>
-                </a:solidFill>
-                <a:latin typeface="Calibri" pitchFamily="34" charset="0"/>
-                <a:ea typeface="Calibri" pitchFamily="34" charset="-122"/>
-                <a:cs typeface="Calibri" pitchFamily="34" charset="-120"/>
-              </a:rPr>
-              <a:t>PDF text loses blank lines</a:t>
+                  <a:srgbClr val="2B1A2E"/>
+                </a:solidFill>
+                <a:latin typeface="Calibri" pitchFamily="34" charset="0"/>
+                <a:ea typeface="Calibri" pitchFamily="34" charset="-122"/>
+                <a:cs typeface="Calibri" pitchFamily="34" charset="-120"/>
+              </a:rPr>
+              <a:t>PDF text loses blank lines, again</a:t>
             </a:r>
             <a:endParaRPr lang="en-US" sz="1600" dirty="0"/>
           </a:p>
@@ -6655,13 +6668,13 @@
             <a:r>
               <a:rPr lang="en-US" sz="1350" dirty="0">
                 <a:solidFill>
-                  <a:srgbClr val="6B7280"/>
-                </a:solidFill>
-                <a:latin typeface="Calibri" pitchFamily="34" charset="0"/>
-                <a:ea typeface="Calibri" pitchFamily="34" charset="-122"/>
-                <a:cs typeface="Calibri" pitchFamily="34" charset="-120"/>
-              </a:rPr>
-              <a:t>pypdf's extract_text() doesn't reliably preserve the blank lines that separated sections on the page. The chunker's blank-line split finds only ONE paragraph for the whole document.</a:t>
+                  <a:srgbClr val="7A6B78"/>
+                </a:solidFill>
+                <a:latin typeface="Calibri" pitchFamily="34" charset="0"/>
+                <a:ea typeface="Calibri" pitchFamily="34" charset="-122"/>
+                <a:cs typeface="Calibri" pitchFamily="34" charset="-120"/>
+              </a:rPr>
+              <a:t>pypdf's extract_text() doesn't preserve the blank lines between this document's five sections. The blank-line chunker finds ONE paragraph for the whole Registration Guide.</a:t>
             </a:r>
             <a:endParaRPr lang="en-US" sz="1350" dirty="0"/>
           </a:p>
@@ -6682,7 +6695,7 @@
             <a:avLst/>
           </a:prstGeom>
           <a:solidFill>
-            <a:srgbClr val="FF6B6B"/>
+            <a:srgbClr val="C45B6E"/>
           </a:solidFill>
           <a:ln/>
         </p:spPr>
@@ -6753,13 +6766,13 @@
             <a:r>
               <a:rPr lang="en-US" sz="1600" b="1" dirty="0">
                 <a:solidFill>
-                  <a:srgbClr val="232B45"/>
-                </a:solidFill>
-                <a:latin typeface="Calibri" pitchFamily="34" charset="0"/>
-                <a:ea typeface="Calibri" pitchFamily="34" charset="-122"/>
-                <a:cs typeface="Calibri" pitchFamily="34" charset="-120"/>
-              </a:rPr>
-              <a:t>target_words never gets a chance to act</a:t>
+                  <a:srgbClr val="2B1A2E"/>
+                </a:solidFill>
+                <a:latin typeface="Calibri" pitchFamily="34" charset="0"/>
+                <a:ea typeface="Calibri" pitchFamily="34" charset="-122"/>
+                <a:cs typeface="Calibri" pitchFamily="34" charset="-120"/>
+              </a:rPr>
+              <a:t>One merged chunk, full of cross-references</a:t>
             </a:r>
             <a:endParaRPr lang="en-US" sz="1600" dirty="0"/>
           </a:p>
@@ -6795,13 +6808,13 @@
             <a:r>
               <a:rPr lang="en-US" sz="1350" dirty="0">
                 <a:solidFill>
-                  <a:srgbClr val="6B7280"/>
-                </a:solidFill>
-                <a:latin typeface="Calibri" pitchFamily="34" charset="0"/>
-                <a:ea typeface="Calibri" pitchFamily="34" charset="-122"/>
-                <a:cs typeface="Calibri" pitchFamily="34" charset="-120"/>
-              </a:rPr>
-              <a:t>With one giant paragraph and nothing to start a new chunk with, changing target_words from 80 to 50 to 25 moves nothing. The bug is upstream of chunk size entirely.</a:t>
+                  <a:srgbClr val="7A6B78"/>
+                </a:solidFill>
+                <a:latin typeface="Calibri" pitchFamily="34" charset="0"/>
+                <a:ea typeface="Calibri" pitchFamily="34" charset="-122"/>
+                <a:cs typeface="Calibri" pitchFamily="34" charset="-120"/>
+              </a:rPr>
+              <a:t>All five sections collapse into one chunk that mentions “course load,” “full-time,” financial aid, and the Academic Standing Policy by name — in passing, not as the actual answer.</a:t>
             </a:r>
             <a:endParaRPr lang="en-US" sz="1350" dirty="0"/>
           </a:p>
@@ -6822,7 +6835,7 @@
             <a:avLst/>
           </a:prstGeom>
           <a:solidFill>
-            <a:srgbClr val="FF6B6B"/>
+            <a:srgbClr val="C45B6E"/>
           </a:solidFill>
           <a:ln/>
         </p:spPr>
@@ -6893,13 +6906,13 @@
             <a:r>
               <a:rPr lang="en-US" sz="1600" b="1" dirty="0">
                 <a:solidFill>
-                  <a:srgbClr val="232B45"/>
-                </a:solidFill>
-                <a:latin typeface="Calibri" pitchFamily="34" charset="0"/>
-                <a:ea typeface="Calibri" pitchFamily="34" charset="-122"/>
-                <a:cs typeface="Calibri" pitchFamily="34" charset="-120"/>
-              </a:rPr>
-              <a:t>The fact gets diluted, not lost</a:t>
+                  <a:srgbClr val="2B1A2E"/>
+                </a:solidFill>
+                <a:latin typeface="Calibri" pitchFamily="34" charset="0"/>
+                <a:ea typeface="Calibri" pitchFamily="34" charset="-122"/>
+                <a:cs typeface="Calibri" pitchFamily="34" charset="-120"/>
+              </a:rPr>
+              <a:t>That cross-referencing language wins by accident</a:t>
             </a:r>
             <a:endParaRPr lang="en-US" sz="1600" dirty="0"/>
           </a:p>
@@ -6935,13 +6948,13 @@
             <a:r>
               <a:rPr lang="en-US" sz="1350" dirty="0">
                 <a:solidFill>
-                  <a:srgbClr val="6B7280"/>
-                </a:solidFill>
-                <a:latin typeface="Calibri" pitchFamily="34" charset="0"/>
-                <a:ea typeface="Calibri" pitchFamily="34" charset="-122"/>
-                <a:cs typeface="Calibri" pitchFamily="34" charset="-120"/>
-              </a:rPr>
-              <a:t>All five sections merge into one 220-word chunk. “Stipend” is a handful of words out of 220 — its vector weight is diluted by four unrelated topics.</a:t>
+                  <a:srgbClr val="7A6B78"/>
+                </a:solidFill>
+                <a:latin typeface="Calibri" pitchFamily="34" charset="0"/>
+                <a:ea typeface="Calibri" pitchFamily="34" charset="-122"/>
+                <a:cs typeface="Calibri" pitchFamily="34" charset="-120"/>
+              </a:rPr>
+              <a:t>Both failing queries share vocabulary with this merged chunk's passing mentions, so it scores deceptively well against questions it can't actually answer.</a:t>
             </a:r>
             <a:endParaRPr lang="en-US" sz="1350" dirty="0"/>
           </a:p>
@@ -6974,7 +6987,7 @@
             <a:r>
               <a:rPr lang="en-US" sz="1000" dirty="0">
                 <a:solidFill>
-                  <a:srgbClr val="6B7280"/>
+                  <a:srgbClr val="7A6B78"/>
                 </a:solidFill>
                 <a:latin typeface="Calibri" pitchFamily="34" charset="0"/>
                 <a:ea typeface="Calibri" pitchFamily="34" charset="-122"/>
@@ -7013,7 +7026,7 @@
             <a:r>
               <a:rPr lang="en-US" sz="1000" dirty="0">
                 <a:solidFill>
-                  <a:srgbClr val="6B7280"/>
+                  <a:srgbClr val="7A6B78"/>
                 </a:solidFill>
                 <a:latin typeface="Calibri" pitchFamily="34" charset="0"/>
                 <a:ea typeface="Calibri" pitchFamily="34" charset="-122"/>
@@ -7084,13 +7097,13 @@
             <a:r>
               <a:rPr lang="en-US" sz="2800" b="1" dirty="0">
                 <a:solidFill>
-                  <a:srgbClr val="232B45"/>
+                  <a:srgbClr val="2B1A2E"/>
                 </a:solidFill>
                 <a:latin typeface="Cambria" pitchFamily="34" charset="0"/>
                 <a:ea typeface="Cambria" pitchFamily="34" charset="-122"/>
                 <a:cs typeface="Cambria" pitchFamily="34" charset="-120"/>
               </a:rPr>
-              <a:t>The fix: split on structure that survives extraction</a:t>
+              <a:t>The fix this time: split on ALL-CAPS headers</a:t>
             </a:r>
             <a:endParaRPr lang="en-US" sz="2800" dirty="0"/>
           </a:p>
@@ -7113,7 +7126,7 @@
             </a:avLst>
           </a:prstGeom>
           <a:solidFill>
-            <a:srgbClr val="F4F6FB"/>
+            <a:srgbClr val="F7F1F4"/>
           </a:solidFill>
           <a:ln/>
           <a:effectLst>
@@ -7140,7 +7153,7 @@
             <a:avLst/>
           </a:prstGeom>
           <a:solidFill>
-            <a:srgbClr val="F4B942"/>
+            <a:srgbClr val="E8B339"/>
           </a:solidFill>
           <a:ln/>
         </p:spPr>
@@ -7199,13 +7212,13 @@
             <a:r>
               <a:rPr lang="en-US" sz="1550" dirty="0">
                 <a:solidFill>
-                  <a:srgbClr val="232B45"/>
-                </a:solidFill>
-                <a:latin typeface="Calibri" pitchFamily="34" charset="0"/>
-                <a:ea typeface="Calibri" pitchFamily="34" charset="-122"/>
-                <a:cs typeface="Calibri" pitchFamily="34" charset="-120"/>
-              </a:rPr>
-              <a:t>Split on numbered section headers (“1. Eligibility”, “2. Remote Work Days”...) instead of blank lines — literal text survives PDF extraction even when layout whitespace doesn't.</a:t>
+                  <a:srgbClr val="2B1A2E"/>
+                </a:solidFill>
+                <a:latin typeface="Calibri" pitchFamily="34" charset="0"/>
+                <a:ea typeface="Calibri" pitchFamily="34" charset="-122"/>
+                <a:cs typeface="Calibri" pitchFamily="34" charset="-120"/>
+              </a:rPr>
+              <a:t>This corpus's headers aren't numbered — they're written in ALL CAPS on their own line (“COURSE LOAD REQUIREMENTS,” “ACADEMIC PROBATION”). Split on THAT pattern instead, since it's what actually survives PDF extraction here.</a:t>
             </a:r>
             <a:endParaRPr lang="en-US" sz="1550" dirty="0"/>
           </a:p>
@@ -7228,7 +7241,7 @@
             </a:avLst>
           </a:prstGeom>
           <a:solidFill>
-            <a:srgbClr val="F4F6FB"/>
+            <a:srgbClr val="F7F1F4"/>
           </a:solidFill>
           <a:ln/>
           <a:effectLst>
@@ -7267,7 +7280,7 @@
             <a:r>
               <a:rPr lang="en-US" sz="1400" b="1" dirty="0">
                 <a:solidFill>
-                  <a:srgbClr val="6B7280"/>
+                  <a:srgbClr val="7A6B78"/>
                 </a:solidFill>
                 <a:latin typeface="Calibri" pitchFamily="34" charset="0"/>
                 <a:ea typeface="Calibri" pitchFamily="34" charset="-122"/>
@@ -7304,17 +7317,17 @@
               <a:buNone/>
             </a:pPr>
             <a:r>
-              <a:rPr lang="en-US" sz="1800" b="1" dirty="0">
-                <a:solidFill>
-                  <a:srgbClr val="232B45"/>
+              <a:rPr lang="en-US" sz="1600" b="1" dirty="0">
+                <a:solidFill>
+                  <a:srgbClr val="2B1A2E"/>
                 </a:solidFill>
                 <a:latin typeface="Cambria" pitchFamily="34" charset="0"/>
                 <a:ea typeface="Cambria" pitchFamily="34" charset="-122"/>
                 <a:cs typeface="Cambria" pitchFamily="34" charset="-120"/>
               </a:rPr>
-              <a:t>expense_policy.pdf</a:t>
-            </a:r>
-            <a:endParaRPr lang="en-US" sz="1800" dirty="0"/>
+              <a:t>registration_guide.pdf</a:t>
+            </a:r>
+            <a:endParaRPr lang="en-US" sz="1600" dirty="0"/>
           </a:p>
         </p:txBody>
       </p:sp>
@@ -7326,7 +7339,7 @@
         </p:nvSpPr>
         <p:spPr>
           <a:xfrm>
-            <a:off x="914400" y="4343400"/>
+            <a:off x="914400" y="4434840"/>
             <a:ext cx="4572000" cy="365760"/>
           </a:xfrm>
           <a:prstGeom prst="rect">
@@ -7345,7 +7358,7 @@
             <a:r>
               <a:rPr lang="en-US" sz="1150" i="1" dirty="0">
                 <a:solidFill>
-                  <a:srgbClr val="6B7280"/>
+                  <a:srgbClr val="7A6B78"/>
                 </a:solidFill>
                 <a:latin typeface="Calibri" pitchFamily="34" charset="0"/>
                 <a:ea typeface="Calibri" pitchFamily="34" charset="-122"/>
@@ -7365,7 +7378,7 @@
         </p:nvSpPr>
         <p:spPr>
           <a:xfrm>
-            <a:off x="914400" y="4846320"/>
+            <a:off x="914400" y="4892040"/>
             <a:ext cx="2286000" cy="457200"/>
           </a:xfrm>
           <a:prstGeom prst="rect">
@@ -7384,13 +7397,13 @@
             <a:r>
               <a:rPr lang="en-US" sz="1600" b="1" dirty="0">
                 <a:solidFill>
-                  <a:srgbClr val="FF6B6B"/>
-                </a:solidFill>
-                <a:latin typeface="Calibri" pitchFamily="34" charset="0"/>
-                <a:ea typeface="Calibri" pitchFamily="34" charset="-122"/>
-                <a:cs typeface="Calibri" pitchFamily="34" charset="-120"/>
-              </a:rPr>
-              <a:t>score: 0.316</a:t>
+                  <a:srgbClr val="C45B6E"/>
+                </a:solidFill>
+                <a:latin typeface="Calibri" pitchFamily="34" charset="0"/>
+                <a:ea typeface="Calibri" pitchFamily="34" charset="-122"/>
+                <a:cs typeface="Calibri" pitchFamily="34" charset="-120"/>
+              </a:rPr>
+              <a:t>score: 0.268</a:t>
             </a:r>
             <a:endParaRPr lang="en-US" sz="1600" dirty="0"/>
           </a:p>
@@ -7404,14 +7417,14 @@
         </p:nvSpPr>
         <p:spPr>
           <a:xfrm>
-            <a:off x="4663440" y="4800600"/>
+            <a:off x="4663440" y="4846320"/>
             <a:ext cx="594360" cy="594360"/>
           </a:xfrm>
           <a:prstGeom prst="ellipse">
             <a:avLst/>
           </a:prstGeom>
           <a:solidFill>
-            <a:srgbClr val="FF6B6B"/>
+            <a:srgbClr val="C45B6E"/>
           </a:solidFill>
           <a:ln/>
         </p:spPr>
@@ -7432,7 +7445,7 @@
         </p:blipFill>
         <p:spPr>
           <a:xfrm>
-            <a:off x="4797171" y="4934331"/>
+            <a:off x="4797171" y="4980051"/>
             <a:ext cx="326898" cy="326898"/>
           </a:xfrm>
           <a:prstGeom prst="rect">
@@ -7457,7 +7470,7 @@
             </a:avLst>
           </a:prstGeom>
           <a:solidFill>
-            <a:srgbClr val="1E2761"/>
+            <a:srgbClr val="4A2545"/>
           </a:solidFill>
           <a:ln/>
           <a:effectLst>
@@ -7496,13 +7509,13 @@
             <a:r>
               <a:rPr lang="en-US" sz="1400" b="1" dirty="0">
                 <a:solidFill>
-                  <a:srgbClr val="CADCFC"/>
-                </a:solidFill>
-                <a:latin typeface="Calibri" pitchFamily="34" charset="0"/>
-                <a:ea typeface="Calibri" pitchFamily="34" charset="-122"/>
-                <a:cs typeface="Calibri" pitchFamily="34" charset="-120"/>
-              </a:rPr>
-              <a:t>After (section-aware chunking)</a:t>
+                  <a:srgbClr val="FBF3E7"/>
+                </a:solidFill>
+                <a:latin typeface="Calibri" pitchFamily="34" charset="0"/>
+                <a:ea typeface="Calibri" pitchFamily="34" charset="-122"/>
+                <a:cs typeface="Calibri" pitchFamily="34" charset="-120"/>
+              </a:rPr>
+              <a:t>After (caps-header chunking)</a:t>
             </a:r>
             <a:endParaRPr lang="en-US" sz="1400" dirty="0"/>
           </a:p>
@@ -7533,7 +7546,7 @@
               <a:buNone/>
             </a:pPr>
             <a:r>
-              <a:rPr lang="en-US" sz="1800" b="1" dirty="0">
+              <a:rPr lang="en-US" sz="1600" b="1" dirty="0">
                 <a:solidFill>
                   <a:srgbClr val="FFFFFF"/>
                 </a:solidFill>
@@ -7541,9 +7554,9 @@
                 <a:ea typeface="Cambria" pitchFamily="34" charset="-122"/>
                 <a:cs typeface="Cambria" pitchFamily="34" charset="-120"/>
               </a:rPr>
-              <a:t>remote_work_policy.pdf</a:t>
-            </a:r>
-            <a:endParaRPr lang="en-US" sz="1800" dirty="0"/>
+              <a:t>academic_standing_policy.pdf</a:t>
+            </a:r>
+            <a:endParaRPr lang="en-US" sz="1600" dirty="0"/>
           </a:p>
         </p:txBody>
       </p:sp>
@@ -7555,7 +7568,7 @@
         </p:nvSpPr>
         <p:spPr>
           <a:xfrm>
-            <a:off x="6355080" y="4343400"/>
+            <a:off x="6355080" y="4434840"/>
             <a:ext cx="4572000" cy="365760"/>
           </a:xfrm>
           <a:prstGeom prst="rect">
@@ -7574,7 +7587,7 @@
             <a:r>
               <a:rPr lang="en-US" sz="1150" i="1" dirty="0">
                 <a:solidFill>
-                  <a:srgbClr val="CADCFC"/>
+                  <a:srgbClr val="FBF3E7"/>
                 </a:solidFill>
                 <a:latin typeface="Calibri" pitchFamily="34" charset="0"/>
                 <a:ea typeface="Calibri" pitchFamily="34" charset="-122"/>
@@ -7594,7 +7607,7 @@
         </p:nvSpPr>
         <p:spPr>
           <a:xfrm>
-            <a:off x="6355080" y="4846320"/>
+            <a:off x="6355080" y="4892040"/>
             <a:ext cx="2286000" cy="457200"/>
           </a:xfrm>
           <a:prstGeom prst="rect">
@@ -7613,13 +7626,13 @@
             <a:r>
               <a:rPr lang="en-US" sz="1600" b="1" dirty="0">
                 <a:solidFill>
-                  <a:srgbClr val="F4B942"/>
-                </a:solidFill>
-                <a:latin typeface="Calibri" pitchFamily="34" charset="0"/>
-                <a:ea typeface="Calibri" pitchFamily="34" charset="-122"/>
-                <a:cs typeface="Calibri" pitchFamily="34" charset="-120"/>
-              </a:rPr>
-              <a:t>score: 0.527</a:t>
+                  <a:srgbClr val="E8B339"/>
+                </a:solidFill>
+                <a:latin typeface="Calibri" pitchFamily="34" charset="0"/>
+                <a:ea typeface="Calibri" pitchFamily="34" charset="-122"/>
+                <a:cs typeface="Calibri" pitchFamily="34" charset="-120"/>
+              </a:rPr>
+              <a:t>score: 0.438</a:t>
             </a:r>
             <a:endParaRPr lang="en-US" sz="1600" dirty="0"/>
           </a:p>
@@ -7633,14 +7646,14 @@
         </p:nvSpPr>
         <p:spPr>
           <a:xfrm>
-            <a:off x="10104120" y="4800600"/>
+            <a:off x="10104120" y="4846320"/>
             <a:ext cx="594360" cy="594360"/>
           </a:xfrm>
           <a:prstGeom prst="ellipse">
             <a:avLst/>
           </a:prstGeom>
           <a:solidFill>
-            <a:srgbClr val="F4B942"/>
+            <a:srgbClr val="E8B339"/>
           </a:solidFill>
           <a:ln/>
         </p:spPr>
@@ -7661,7 +7674,7 @@
         </p:blipFill>
         <p:spPr>
           <a:xfrm>
-            <a:off x="10237851" y="4934331"/>
+            <a:off x="10237851" y="4980051"/>
             <a:ext cx="326898" cy="326898"/>
           </a:xfrm>
           <a:prstGeom prst="rect">
@@ -7696,7 +7709,7 @@
             <a:r>
               <a:rPr lang="en-US" sz="1000" dirty="0">
                 <a:solidFill>
-                  <a:srgbClr val="6B7280"/>
+                  <a:srgbClr val="7A6B78"/>
                 </a:solidFill>
                 <a:latin typeface="Calibri" pitchFamily="34" charset="0"/>
                 <a:ea typeface="Calibri" pitchFamily="34" charset="-122"/>
@@ -7735,7 +7748,7 @@
             <a:r>
               <a:rPr lang="en-US" sz="1000" dirty="0">
                 <a:solidFill>
-                  <a:srgbClr val="6B7280"/>
+                  <a:srgbClr val="7A6B78"/>
                 </a:solidFill>
                 <a:latin typeface="Calibri" pitchFamily="34" charset="0"/>
                 <a:ea typeface="Calibri" pitchFamily="34" charset="-122"/>
@@ -7806,13 +7819,13 @@
             <a:r>
               <a:rPr lang="en-US" sz="2800" b="1" dirty="0">
                 <a:solidFill>
-                  <a:srgbClr val="232B45"/>
+                  <a:srgbClr val="2B1A2E"/>
                 </a:solidFill>
                 <a:latin typeface="Cambria" pitchFamily="34" charset="0"/>
                 <a:ea typeface="Cambria" pitchFamily="34" charset="-122"/>
                 <a:cs typeface="Cambria" pitchFamily="34" charset="-120"/>
               </a:rPr>
-              <a:t>Make wrong-document retrieval visible, not silent</a:t>
+              <a:t>The transferable lesson is a principle, not a regex</a:t>
             </a:r>
             <a:endParaRPr lang="en-US" sz="2800" dirty="0"/>
           </a:p>
@@ -7845,13 +7858,13 @@
             <a:r>
               <a:rPr lang="en-US" sz="1300" b="1" dirty="0">
                 <a:solidFill>
-                  <a:srgbClr val="6B7280"/>
-                </a:solidFill>
-                <a:latin typeface="Calibri" pitchFamily="34" charset="0"/>
-                <a:ea typeface="Calibri" pitchFamily="34" charset="-122"/>
-                <a:cs typeface="Calibri" pitchFamily="34" charset="-120"/>
-              </a:rPr>
-              <a:t>Session 3.4 — single document</a:t>
+                  <a:srgbClr val="7A6B78"/>
+                </a:solidFill>
+                <a:latin typeface="Calibri" pitchFamily="34" charset="0"/>
+                <a:ea typeface="Calibri" pitchFamily="34" charset="-122"/>
+                <a:cs typeface="Calibri" pitchFamily="34" charset="-120"/>
+              </a:rPr>
+              <a:t>Earlier fix: numbered headers</a:t>
             </a:r>
             <a:endParaRPr lang="en-US" sz="1300" dirty="0"/>
           </a:p>
@@ -7874,7 +7887,7 @@
             </a:avLst>
           </a:prstGeom>
           <a:solidFill>
-            <a:srgbClr val="F4F6FB"/>
+            <a:srgbClr val="F7F1F4"/>
           </a:solidFill>
           <a:ln/>
         </p:spPr>
@@ -7904,15 +7917,49 @@
               <a:buNone/>
             </a:pPr>
             <a:r>
-              <a:rPr lang="en-US" sz="1400" i="1" dirty="0">
-                <a:solidFill>
-                  <a:srgbClr val="232B45"/>
-                </a:solidFill>
-                <a:latin typeface="Calibri" pitchFamily="34" charset="0"/>
-                <a:ea typeface="Calibri" pitchFamily="34" charset="-122"/>
-                <a:cs typeface="Calibri" pitchFamily="34" charset="-120"/>
-              </a:rPr>
-              <a:t>“...employees get 18 PTO days per year [1].”</a:t>
+              <a:rPr lang="en-US" sz="1400" dirty="0">
+                <a:solidFill>
+                  <a:srgbClr val="2B1A2E"/>
+                </a:solidFill>
+                <a:latin typeface="Calibri" pitchFamily="34" charset="0"/>
+                <a:ea typeface="Calibri" pitchFamily="34" charset="-122"/>
+                <a:cs typeface="Calibri" pitchFamily="34" charset="-120"/>
+              </a:rPr>
+              <a:t>“1. Eligibility”</a:t>
+            </a:r>
+            <a:endParaRPr lang="en-US" sz="1400" dirty="0"/>
+          </a:p>
+          <a:p>
+            <a:pPr indent="0" marL="0">
+              <a:buNone/>
+            </a:pPr>
+            <a:r>
+              <a:rPr lang="en-US" sz="1400" dirty="0">
+                <a:solidFill>
+                  <a:srgbClr val="2B1A2E"/>
+                </a:solidFill>
+                <a:latin typeface="Calibri" pitchFamily="34" charset="0"/>
+                <a:ea typeface="Calibri" pitchFamily="34" charset="-122"/>
+                <a:cs typeface="Calibri" pitchFamily="34" charset="-120"/>
+              </a:rPr>
+              <a:t>“2. Remote Work Days”</a:t>
+            </a:r>
+            <a:endParaRPr lang="en-US" sz="1400" dirty="0"/>
+          </a:p>
+          <a:p>
+            <a:pPr indent="0" marL="0">
+              <a:buNone/>
+            </a:pPr>
+            <a:r>
+              <a:rPr lang="en-US" sz="1400" dirty="0">
+                <a:solidFill>
+                  <a:srgbClr val="2B1A2E"/>
+                </a:solidFill>
+                <a:latin typeface="Calibri" pitchFamily="34" charset="0"/>
+                <a:ea typeface="Calibri" pitchFamily="34" charset="-122"/>
+                <a:cs typeface="Calibri" pitchFamily="34" charset="-120"/>
+              </a:rPr>
+              <a:t>→ split on \n\d+\.\s</a:t>
             </a:r>
             <a:endParaRPr lang="en-US" sz="1400" dirty="0"/>
           </a:p>
@@ -7945,13 +7992,13 @@
             <a:r>
               <a:rPr lang="en-US" sz="1300" b="1" dirty="0">
                 <a:solidFill>
-                  <a:srgbClr val="FF6B6B"/>
-                </a:solidFill>
-                <a:latin typeface="Calibri" pitchFamily="34" charset="0"/>
-                <a:ea typeface="Calibri" pitchFamily="34" charset="-122"/>
-                <a:cs typeface="Calibri" pitchFamily="34" charset="-120"/>
-              </a:rPr>
-              <a:t>Session 3.6 — multi document (today)</a:t>
+                  <a:srgbClr val="C45B6E"/>
+                </a:solidFill>
+                <a:latin typeface="Calibri" pitchFamily="34" charset="0"/>
+                <a:ea typeface="Calibri" pitchFamily="34" charset="-122"/>
+                <a:cs typeface="Calibri" pitchFamily="34" charset="-120"/>
+              </a:rPr>
+              <a:t>This corpus: ALL-CAPS headers</a:t>
             </a:r>
             <a:endParaRPr lang="en-US" sz="1300" dirty="0"/>
           </a:p>
@@ -7974,7 +8021,7 @@
             </a:avLst>
           </a:prstGeom>
           <a:solidFill>
-            <a:srgbClr val="1E2761"/>
+            <a:srgbClr val="4A2545"/>
           </a:solidFill>
           <a:ln/>
         </p:spPr>
@@ -8004,7 +8051,7 @@
               <a:buNone/>
             </a:pPr>
             <a:r>
-              <a:rPr lang="en-US" sz="1400" i="1" dirty="0">
+              <a:rPr lang="en-US" sz="1400" dirty="0">
                 <a:solidFill>
                   <a:srgbClr val="FFFFFF"/>
                 </a:solidFill>
@@ -8012,7 +8059,7 @@
                 <a:ea typeface="Calibri" pitchFamily="34" charset="-122"/>
                 <a:cs typeface="Calibri" pitchFamily="34" charset="-120"/>
               </a:rPr>
-              <a:t>“...employees get 18 PTO days per year [1].”</a:t>
+              <a:t>“COURSE LOAD REQUIREMENTS”</a:t>
             </a:r>
             <a:endParaRPr lang="en-US" sz="1400" dirty="0"/>
           </a:p>
@@ -8021,7 +8068,7 @@
               <a:buNone/>
             </a:pPr>
             <a:r>
-              <a:rPr lang="en-US" sz="1400" i="1" dirty="0">
+              <a:rPr lang="en-US" sz="1400" dirty="0">
                 <a:solidFill>
                   <a:srgbClr val="FFFFFF"/>
                 </a:solidFill>
@@ -8029,7 +8076,24 @@
                 <a:ea typeface="Calibri" pitchFamily="34" charset="-122"/>
                 <a:cs typeface="Calibri" pitchFamily="34" charset="-120"/>
               </a:rPr>
-              <a:t>[1] Source: Leave Policy</a:t>
+              <a:t>“ACADEMIC PROBATION”</a:t>
+            </a:r>
+            <a:endParaRPr lang="en-US" sz="1400" dirty="0"/>
+          </a:p>
+          <a:p>
+            <a:pPr indent="0" marL="0">
+              <a:buNone/>
+            </a:pPr>
+            <a:r>
+              <a:rPr lang="en-US" sz="1400" dirty="0">
+                <a:solidFill>
+                  <a:srgbClr val="FFFFFF"/>
+                </a:solidFill>
+                <a:latin typeface="Calibri" pitchFamily="34" charset="0"/>
+                <a:ea typeface="Calibri" pitchFamily="34" charset="-122"/>
+                <a:cs typeface="Calibri" pitchFamily="34" charset="-120"/>
+              </a:rPr>
+              <a:t>→ split on \n[A-Z][A-Z /]+\n</a:t>
             </a:r>
             <a:endParaRPr lang="en-US" sz="1400" dirty="0"/>
           </a:p>
@@ -8052,7 +8116,7 @@
             </a:avLst>
           </a:prstGeom>
           <a:solidFill>
-            <a:srgbClr val="F4F6FB"/>
+            <a:srgbClr val="F7F1F4"/>
           </a:solidFill>
           <a:ln/>
           <a:effectLst>
@@ -8079,14 +8143,14 @@
             <a:avLst/>
           </a:prstGeom>
           <a:solidFill>
-            <a:srgbClr val="FF6B6B"/>
+            <a:srgbClr val="C45B6E"/>
           </a:solidFill>
           <a:ln/>
         </p:spPr>
       </p:sp>
       <p:pic>
         <p:nvPicPr>
-          <p:cNvPr id="11" name="Image 0" descr="icon_tags_white.png">    </p:cNvPr>
+          <p:cNvPr id="11" name="Image 0" descr="icon_diagram_white.png">    </p:cNvPr>
           <p:cNvPicPr>
             <a:picLocks noChangeAspect="1"/>
           </p:cNvPicPr>
@@ -8138,13 +8202,13 @@
             <a:r>
               <a:rPr lang="en-US" sz="1500" dirty="0">
                 <a:solidFill>
-                  <a:srgbClr val="232B45"/>
-                </a:solidFill>
-                <a:latin typeface="Calibri" pitchFamily="34" charset="0"/>
-                <a:ea typeface="Calibri" pitchFamily="34" charset="-122"/>
-                <a:cs typeface="Calibri" pitchFamily="34" charset="-120"/>
-              </a:rPr>
-              <a:t>If a VPN question gets answered with “[1]”, you have to dig into the raw chunk text to check it's really grounded in the IT Security Policy. If it says “[1] Source: IT Security Policy,” a wrong-document retrieval is visible the instant you glance at the citation — to a user, a reviewer, or you, debugging at 11pm.</a:t>
+                  <a:srgbClr val="2B1A2E"/>
+                </a:solidFill>
+                <a:latin typeface="Calibri" pitchFamily="34" charset="0"/>
+                <a:ea typeface="Calibri" pitchFamily="34" charset="-122"/>
+                <a:cs typeface="Calibri" pitchFamily="34" charset="-120"/>
+              </a:rPr>
+              <a:t>Different code, same underlying principle: inspect how YOUR real documents are actually structured after extraction, find a pattern that reliably survives, and verify the fix by running it — don't assume a fix that worked on a previous document set will transfer automatically to a new one.</a:t>
             </a:r>
             <a:endParaRPr lang="en-US" sz="1500" dirty="0"/>
           </a:p>
@@ -8177,7 +8241,7 @@
             <a:r>
               <a:rPr lang="en-US" sz="1000" dirty="0">
                 <a:solidFill>
-                  <a:srgbClr val="6B7280"/>
+                  <a:srgbClr val="7A6B78"/>
                 </a:solidFill>
                 <a:latin typeface="Calibri" pitchFamily="34" charset="0"/>
                 <a:ea typeface="Calibri" pitchFamily="34" charset="-122"/>
@@ -8216,7 +8280,7 @@
             <a:r>
               <a:rPr lang="en-US" sz="1000" dirty="0">
                 <a:solidFill>
-                  <a:srgbClr val="6B7280"/>
+                  <a:srgbClr val="7A6B78"/>
                 </a:solidFill>
                 <a:latin typeface="Calibri" pitchFamily="34" charset="0"/>
                 <a:ea typeface="Calibri" pitchFamily="34" charset="-122"/>

</xml_diff>